<commit_message>
added code to test out baseline implementation of iceberg compilation
</commit_message>
<xml_diff>
--- a/direction.pptx
+++ b/direction.pptx
@@ -16,6 +16,17 @@
     <p:sldId id="263" r:id="rId10"/>
     <p:sldId id="264" r:id="rId11"/>
     <p:sldId id="266" r:id="rId12"/>
+    <p:sldId id="267" r:id="rId13"/>
+    <p:sldId id="271" r:id="rId14"/>
+    <p:sldId id="268" r:id="rId15"/>
+    <p:sldId id="269" r:id="rId16"/>
+    <p:sldId id="270" r:id="rId17"/>
+    <p:sldId id="272" r:id="rId18"/>
+    <p:sldId id="273" r:id="rId19"/>
+    <p:sldId id="274" r:id="rId20"/>
+    <p:sldId id="275" r:id="rId21"/>
+    <p:sldId id="276" r:id="rId22"/>
+    <p:sldId id="277" r:id="rId23"/>
   </p:sldIdLst>
   <p:sldSz cx="12192000" cy="6858000"/>
   <p:notesSz cx="6858000" cy="9144000"/>
@@ -271,7 +282,7 @@
           <a:p>
             <a:fld id="{B74604FD-B602-FC49-9746-E8C71C959787}" type="datetimeFigureOut">
               <a:rPr lang="en-US" smtClean="0"/>
-              <a:t>3/28/25</a:t>
+              <a:t>4/18/25</a:t>
             </a:fld>
             <a:endParaRPr lang="en-US"/>
           </a:p>
@@ -471,7 +482,7 @@
           <a:p>
             <a:fld id="{B74604FD-B602-FC49-9746-E8C71C959787}" type="datetimeFigureOut">
               <a:rPr lang="en-US" smtClean="0"/>
-              <a:t>3/28/25</a:t>
+              <a:t>4/18/25</a:t>
             </a:fld>
             <a:endParaRPr lang="en-US"/>
           </a:p>
@@ -681,7 +692,7 @@
           <a:p>
             <a:fld id="{B74604FD-B602-FC49-9746-E8C71C959787}" type="datetimeFigureOut">
               <a:rPr lang="en-US" smtClean="0"/>
-              <a:t>3/28/25</a:t>
+              <a:t>4/18/25</a:t>
             </a:fld>
             <a:endParaRPr lang="en-US"/>
           </a:p>
@@ -881,7 +892,7 @@
           <a:p>
             <a:fld id="{B74604FD-B602-FC49-9746-E8C71C959787}" type="datetimeFigureOut">
               <a:rPr lang="en-US" smtClean="0"/>
-              <a:t>3/28/25</a:t>
+              <a:t>4/18/25</a:t>
             </a:fld>
             <a:endParaRPr lang="en-US"/>
           </a:p>
@@ -1157,7 +1168,7 @@
           <a:p>
             <a:fld id="{B74604FD-B602-FC49-9746-E8C71C959787}" type="datetimeFigureOut">
               <a:rPr lang="en-US" smtClean="0"/>
-              <a:t>3/28/25</a:t>
+              <a:t>4/18/25</a:t>
             </a:fld>
             <a:endParaRPr lang="en-US"/>
           </a:p>
@@ -1425,7 +1436,7 @@
           <a:p>
             <a:fld id="{B74604FD-B602-FC49-9746-E8C71C959787}" type="datetimeFigureOut">
               <a:rPr lang="en-US" smtClean="0"/>
-              <a:t>3/28/25</a:t>
+              <a:t>4/18/25</a:t>
             </a:fld>
             <a:endParaRPr lang="en-US"/>
           </a:p>
@@ -1840,7 +1851,7 @@
           <a:p>
             <a:fld id="{B74604FD-B602-FC49-9746-E8C71C959787}" type="datetimeFigureOut">
               <a:rPr lang="en-US" smtClean="0"/>
-              <a:t>3/28/25</a:t>
+              <a:t>4/18/25</a:t>
             </a:fld>
             <a:endParaRPr lang="en-US"/>
           </a:p>
@@ -1982,7 +1993,7 @@
           <a:p>
             <a:fld id="{B74604FD-B602-FC49-9746-E8C71C959787}" type="datetimeFigureOut">
               <a:rPr lang="en-US" smtClean="0"/>
-              <a:t>3/28/25</a:t>
+              <a:t>4/18/25</a:t>
             </a:fld>
             <a:endParaRPr lang="en-US"/>
           </a:p>
@@ -2095,7 +2106,7 @@
           <a:p>
             <a:fld id="{B74604FD-B602-FC49-9746-E8C71C959787}" type="datetimeFigureOut">
               <a:rPr lang="en-US" smtClean="0"/>
-              <a:t>3/28/25</a:t>
+              <a:t>4/18/25</a:t>
             </a:fld>
             <a:endParaRPr lang="en-US"/>
           </a:p>
@@ -2408,7 +2419,7 @@
           <a:p>
             <a:fld id="{B74604FD-B602-FC49-9746-E8C71C959787}" type="datetimeFigureOut">
               <a:rPr lang="en-US" smtClean="0"/>
-              <a:t>3/28/25</a:t>
+              <a:t>4/18/25</a:t>
             </a:fld>
             <a:endParaRPr lang="en-US"/>
           </a:p>
@@ -2697,7 +2708,7 @@
           <a:p>
             <a:fld id="{B74604FD-B602-FC49-9746-E8C71C959787}" type="datetimeFigureOut">
               <a:rPr lang="en-US" smtClean="0"/>
-              <a:t>3/28/25</a:t>
+              <a:t>4/18/25</a:t>
             </a:fld>
             <a:endParaRPr lang="en-US"/>
           </a:p>
@@ -2940,7 +2951,7 @@
           <a:p>
             <a:fld id="{B74604FD-B602-FC49-9746-E8C71C959787}" type="datetimeFigureOut">
               <a:rPr lang="en-US" smtClean="0"/>
-              <a:t>3/28/25</a:t>
+              <a:t>4/18/25</a:t>
             </a:fld>
             <a:endParaRPr lang="en-US"/>
           </a:p>
@@ -3501,8 +3512,8 @@
           </a:p>
         </p:txBody>
       </p:sp>
-      <mc:AlternateContent xmlns:mc="http://schemas.openxmlformats.org/markup-compatibility/2006">
-        <mc:Choice xmlns:a14="http://schemas.microsoft.com/office/drawing/2010/main" Requires="a14">
+      <mc:AlternateContent xmlns:mc="http://schemas.openxmlformats.org/markup-compatibility/2006" xmlns:a14="http://schemas.microsoft.com/office/drawing/2010/main">
+        <mc:Choice Requires="a14">
           <p:sp>
             <p:nvSpPr>
               <p:cNvPr id="3" name="Content Placeholder 2">
@@ -3654,7 +3665,7 @@
             </p:txBody>
           </p:sp>
         </mc:Choice>
-        <mc:Fallback>
+        <mc:Fallback xmlns="">
           <p:sp>
             <p:nvSpPr>
               <p:cNvPr id="3" name="Content Placeholder 2">
@@ -3726,13 +3737,7 @@
               <a:rPr lang="en-GB" sz="1800" dirty="0">
                 <a:hlinkClick r:id="rId3"/>
               </a:rPr>
-              <a:t>[1] </a:t>
-            </a:r>
-            <a:r>
-              <a:rPr lang="en-GB" sz="1800" dirty="0">
-                <a:hlinkClick r:id="rId3"/>
-              </a:rPr>
-              <a:t>https://doi.org/10.1103/PRXQuantum.5.010337</a:t>
+              <a:t>[1] https://doi.org/10.1103/PRXQuantum.5.010337</a:t>
             </a:r>
             <a:endParaRPr lang="en-GB" sz="1800" dirty="0"/>
           </a:p>
@@ -3820,8 +3825,8 @@
           </a:p>
         </p:txBody>
       </p:sp>
-      <mc:AlternateContent xmlns:mc="http://schemas.openxmlformats.org/markup-compatibility/2006">
-        <mc:Choice xmlns:a14="http://schemas.microsoft.com/office/drawing/2010/main" Requires="a14">
+      <mc:AlternateContent xmlns:mc="http://schemas.openxmlformats.org/markup-compatibility/2006" xmlns:a14="http://schemas.microsoft.com/office/drawing/2010/main">
+        <mc:Choice Requires="a14">
           <p:sp>
             <p:nvSpPr>
               <p:cNvPr id="3" name="Content Placeholder 2">
@@ -3937,7 +3942,7 @@
             </p:txBody>
           </p:sp>
         </mc:Choice>
-        <mc:Fallback>
+        <mc:Fallback xmlns="">
           <p:sp>
             <p:nvSpPr>
               <p:cNvPr id="3" name="Content Placeholder 2">
@@ -3990,6 +3995,1238 @@
 </p:sld>
 </file>
 
+<file path=ppt/slides/slide12.xml><?xml version="1.0" encoding="utf-8"?>
+<p:sld xmlns:a="http://schemas.openxmlformats.org/drawingml/2006/main" xmlns:r="http://schemas.openxmlformats.org/officeDocument/2006/relationships" xmlns:p="http://schemas.openxmlformats.org/presentationml/2006/main">
+  <p:cSld>
+    <p:spTree>
+      <p:nvGrpSpPr>
+        <p:cNvPr id="1" name=""/>
+        <p:cNvGrpSpPr/>
+        <p:nvPr/>
+      </p:nvGrpSpPr>
+      <p:grpSpPr>
+        <a:xfrm>
+          <a:off x="0" y="0"/>
+          <a:ext cx="0" cy="0"/>
+          <a:chOff x="0" y="0"/>
+          <a:chExt cx="0" cy="0"/>
+        </a:xfrm>
+      </p:grpSpPr>
+      <p:sp>
+        <p:nvSpPr>
+          <p:cNvPr id="2" name="Title 1">
+            <a:extLst>
+              <a:ext uri="{FF2B5EF4-FFF2-40B4-BE49-F238E27FC236}">
+                <a16:creationId xmlns:a16="http://schemas.microsoft.com/office/drawing/2014/main" id="{D79BB1A6-2C0B-91E9-9B37-2AB9634C1251}"/>
+              </a:ext>
+            </a:extLst>
+          </p:cNvPr>
+          <p:cNvSpPr>
+            <a:spLocks noGrp="1"/>
+          </p:cNvSpPr>
+          <p:nvPr>
+            <p:ph type="title"/>
+          </p:nvPr>
+        </p:nvSpPr>
+        <p:spPr/>
+        <p:txBody>
+          <a:bodyPr/>
+          <a:lstStyle/>
+          <a:p>
+            <a:r>
+              <a:rPr lang="en-GB" dirty="0"/>
+              <a:t>Logical Operators</a:t>
+            </a:r>
+          </a:p>
+        </p:txBody>
+      </p:sp>
+      <mc:AlternateContent xmlns:mc="http://schemas.openxmlformats.org/markup-compatibility/2006" xmlns:a14="http://schemas.microsoft.com/office/drawing/2010/main">
+        <mc:Choice Requires="a14">
+          <p:sp>
+            <p:nvSpPr>
+              <p:cNvPr id="3" name="Content Placeholder 2">
+                <a:extLst>
+                  <a:ext uri="{FF2B5EF4-FFF2-40B4-BE49-F238E27FC236}">
+                    <a16:creationId xmlns:a16="http://schemas.microsoft.com/office/drawing/2014/main" id="{EC5AF95B-9E78-6BDB-528F-6563A96636E0}"/>
+                  </a:ext>
+                </a:extLst>
+              </p:cNvPr>
+              <p:cNvSpPr>
+                <a:spLocks noGrp="1"/>
+              </p:cNvSpPr>
+              <p:nvPr>
+                <p:ph idx="1"/>
+              </p:nvPr>
+            </p:nvSpPr>
+            <p:spPr/>
+            <p:txBody>
+              <a:bodyPr>
+                <a:normAutofit lnSpcReduction="10000"/>
+              </a:bodyPr>
+              <a:lstStyle/>
+              <a:p>
+                <a:r>
+                  <a:rPr lang="en-GB" dirty="0"/>
+                  <a:t>It is possible to find the logical Pauli operators, albeit it takes exponential time: </a:t>
+                </a:r>
+                <a14:m>
+                  <m:oMath xmlns:m="http://schemas.openxmlformats.org/officeDocument/2006/math">
+                    <m:r>
+                      <a:rPr lang="en-US" b="0" i="1" smtClean="0">
+                        <a:latin typeface="Cambria Math" panose="02040503050406030204" pitchFamily="18" charset="0"/>
+                      </a:rPr>
+                      <m:t>𝑂</m:t>
+                    </m:r>
+                    <m:r>
+                      <a:rPr lang="en-US" b="0" i="1" smtClean="0">
+                        <a:latin typeface="Cambria Math" panose="02040503050406030204" pitchFamily="18" charset="0"/>
+                      </a:rPr>
+                      <m:t>(</m:t>
+                    </m:r>
+                    <m:r>
+                      <a:rPr lang="en-US" b="0" i="1" smtClean="0">
+                        <a:latin typeface="Cambria Math" panose="02040503050406030204" pitchFamily="18" charset="0"/>
+                      </a:rPr>
+                      <m:t>𝑛</m:t>
+                    </m:r>
+                    <m:r>
+                      <a:rPr lang="en-US" b="0" i="1" smtClean="0">
+                        <a:latin typeface="Cambria Math" panose="02040503050406030204" pitchFamily="18" charset="0"/>
+                      </a:rPr>
+                      <m:t> </m:t>
+                    </m:r>
+                    <m:sSup>
+                      <m:sSupPr>
+                        <m:ctrlPr>
+                          <a:rPr lang="en-US" b="0" i="1" smtClean="0">
+                            <a:latin typeface="Cambria Math" panose="02040503050406030204" pitchFamily="18" charset="0"/>
+                          </a:rPr>
+                        </m:ctrlPr>
+                      </m:sSupPr>
+                      <m:e>
+                        <m:r>
+                          <a:rPr lang="en-US" b="0" i="1" smtClean="0">
+                            <a:latin typeface="Cambria Math" panose="02040503050406030204" pitchFamily="18" charset="0"/>
+                          </a:rPr>
+                          <m:t>4</m:t>
+                        </m:r>
+                      </m:e>
+                      <m:sup>
+                        <m:r>
+                          <a:rPr lang="en-US" b="0" i="1" smtClean="0">
+                            <a:latin typeface="Cambria Math" panose="02040503050406030204" pitchFamily="18" charset="0"/>
+                          </a:rPr>
+                          <m:t>𝑛</m:t>
+                        </m:r>
+                      </m:sup>
+                    </m:sSup>
+                    <m:r>
+                      <a:rPr lang="en-US" b="0" i="1" smtClean="0">
+                        <a:latin typeface="Cambria Math" panose="02040503050406030204" pitchFamily="18" charset="0"/>
+                      </a:rPr>
+                      <m:t>)</m:t>
+                    </m:r>
+                  </m:oMath>
+                </a14:m>
+                <a:endParaRPr lang="en-GB" dirty="0"/>
+              </a:p>
+              <a:p>
+                <a:pPr lvl="1"/>
+                <a:r>
+                  <a:rPr lang="en-GB" dirty="0"/>
+                  <a:t>Made a program to find the logical Paulis given the stabilizers as input</a:t>
+                </a:r>
+              </a:p>
+              <a:p>
+                <a:endParaRPr lang="en-GB" dirty="0"/>
+              </a:p>
+              <a:p>
+                <a:r>
+                  <a:rPr lang="en-GB" dirty="0"/>
+                  <a:t>However, it is much harder to:</a:t>
+                </a:r>
+              </a:p>
+              <a:p>
+                <a:pPr marL="914400" lvl="1" indent="-457200">
+                  <a:buFont typeface="+mj-lt"/>
+                  <a:buAutoNum type="arabicPeriod"/>
+                </a:pPr>
+                <a:r>
+                  <a:rPr lang="en-GB" dirty="0"/>
+                  <a:t>Find the logical </a:t>
+                </a:r>
+                <a:r>
+                  <a:rPr lang="en-GB" dirty="0" err="1"/>
+                  <a:t>Cliffords</a:t>
+                </a:r>
+                <a:endParaRPr lang="en-GB" dirty="0"/>
+              </a:p>
+              <a:p>
+                <a:pPr marL="914400" lvl="1" indent="-457200">
+                  <a:buFont typeface="+mj-lt"/>
+                  <a:buAutoNum type="arabicPeriod"/>
+                </a:pPr>
+                <a:r>
+                  <a:rPr lang="en-GB" dirty="0"/>
+                  <a:t>Check if the </a:t>
+                </a:r>
+                <a:r>
+                  <a:rPr lang="en-GB" dirty="0" err="1"/>
+                  <a:t>Cliffords</a:t>
+                </a:r>
+                <a:r>
+                  <a:rPr lang="en-GB" dirty="0"/>
+                  <a:t> found in step 1 are Fault-Tolerant</a:t>
+                </a:r>
+              </a:p>
+              <a:p>
+                <a:endParaRPr lang="en-GB" dirty="0"/>
+              </a:p>
+              <a:p>
+                <a:r>
+                  <a:rPr lang="en-GB" dirty="0"/>
+                  <a:t>Step 1 requires a search over all unitaries of size n in the general case</a:t>
+                </a:r>
+              </a:p>
+            </p:txBody>
+          </p:sp>
+        </mc:Choice>
+        <mc:Fallback xmlns="">
+          <p:sp>
+            <p:nvSpPr>
+              <p:cNvPr id="3" name="Content Placeholder 2">
+                <a:extLst>
+                  <a:ext uri="{FF2B5EF4-FFF2-40B4-BE49-F238E27FC236}">
+                    <a16:creationId xmlns:a16="http://schemas.microsoft.com/office/drawing/2014/main" id="{EC5AF95B-9E78-6BDB-528F-6563A96636E0}"/>
+                  </a:ext>
+                </a:extLst>
+              </p:cNvPr>
+              <p:cNvSpPr>
+                <a:spLocks noGrp="1" noRot="1" noChangeAspect="1" noMove="1" noResize="1" noEditPoints="1" noAdjustHandles="1" noChangeArrowheads="1" noChangeShapeType="1" noTextEdit="1"/>
+              </p:cNvSpPr>
+              <p:nvPr>
+                <p:ph idx="1"/>
+              </p:nvPr>
+            </p:nvSpPr>
+            <p:spPr>
+              <a:blipFill>
+                <a:blip r:embed="rId2"/>
+                <a:stretch>
+                  <a:fillRect l="-1086" t="-3198"/>
+                </a:stretch>
+              </a:blipFill>
+            </p:spPr>
+            <p:txBody>
+              <a:bodyPr/>
+              <a:lstStyle/>
+              <a:p>
+                <a:r>
+                  <a:rPr lang="en-GB">
+                    <a:noFill/>
+                  </a:rPr>
+                  <a:t> </a:t>
+                </a:r>
+              </a:p>
+            </p:txBody>
+          </p:sp>
+        </mc:Fallback>
+      </mc:AlternateContent>
+    </p:spTree>
+    <p:extLst>
+      <p:ext uri="{BB962C8B-B14F-4D97-AF65-F5344CB8AC3E}">
+        <p14:creationId xmlns:p14="http://schemas.microsoft.com/office/powerpoint/2010/main" val="3418770365"/>
+      </p:ext>
+    </p:extLst>
+  </p:cSld>
+  <p:clrMapOvr>
+    <a:masterClrMapping/>
+  </p:clrMapOvr>
+</p:sld>
+</file>
+
+<file path=ppt/slides/slide13.xml><?xml version="1.0" encoding="utf-8"?>
+<p:sld xmlns:a="http://schemas.openxmlformats.org/drawingml/2006/main" xmlns:r="http://schemas.openxmlformats.org/officeDocument/2006/relationships" xmlns:p="http://schemas.openxmlformats.org/presentationml/2006/main">
+  <p:cSld>
+    <p:spTree>
+      <p:nvGrpSpPr>
+        <p:cNvPr id="1" name=""/>
+        <p:cNvGrpSpPr/>
+        <p:nvPr/>
+      </p:nvGrpSpPr>
+      <p:grpSpPr>
+        <a:xfrm>
+          <a:off x="0" y="0"/>
+          <a:ext cx="0" cy="0"/>
+          <a:chOff x="0" y="0"/>
+          <a:chExt cx="0" cy="0"/>
+        </a:xfrm>
+      </p:grpSpPr>
+      <p:sp>
+        <p:nvSpPr>
+          <p:cNvPr id="2" name="Title 1">
+            <a:extLst>
+              <a:ext uri="{FF2B5EF4-FFF2-40B4-BE49-F238E27FC236}">
+                <a16:creationId xmlns:a16="http://schemas.microsoft.com/office/drawing/2014/main" id="{011EBF9A-7CE7-351E-BECF-5E24A473291C}"/>
+              </a:ext>
+            </a:extLst>
+          </p:cNvPr>
+          <p:cNvSpPr>
+            <a:spLocks noGrp="1"/>
+          </p:cNvSpPr>
+          <p:nvPr>
+            <p:ph type="title"/>
+          </p:nvPr>
+        </p:nvSpPr>
+        <p:spPr/>
+        <p:txBody>
+          <a:bodyPr/>
+          <a:lstStyle/>
+          <a:p>
+            <a:r>
+              <a:rPr lang="en-GB" dirty="0"/>
+              <a:t>Logical Operators</a:t>
+            </a:r>
+          </a:p>
+        </p:txBody>
+      </p:sp>
+      <p:pic>
+        <p:nvPicPr>
+          <p:cNvPr id="6" name="Picture 5">
+            <a:extLst>
+              <a:ext uri="{FF2B5EF4-FFF2-40B4-BE49-F238E27FC236}">
+                <a16:creationId xmlns:a16="http://schemas.microsoft.com/office/drawing/2014/main" id="{E4CCAB0D-8E27-540C-831A-4B88E1ABF436}"/>
+              </a:ext>
+            </a:extLst>
+          </p:cNvPr>
+          <p:cNvPicPr>
+            <a:picLocks noChangeAspect="1"/>
+          </p:cNvPicPr>
+          <p:nvPr/>
+        </p:nvPicPr>
+        <p:blipFill>
+          <a:blip r:embed="rId2"/>
+          <a:stretch>
+            <a:fillRect/>
+          </a:stretch>
+        </p:blipFill>
+        <p:spPr>
+          <a:xfrm>
+            <a:off x="1435031" y="3429000"/>
+            <a:ext cx="9321938" cy="1249680"/>
+          </a:xfrm>
+          <a:prstGeom prst="rect">
+            <a:avLst/>
+          </a:prstGeom>
+          <a:ln>
+            <a:solidFill>
+              <a:schemeClr val="accent1"/>
+            </a:solidFill>
+          </a:ln>
+        </p:spPr>
+      </p:pic>
+      <p:pic>
+        <p:nvPicPr>
+          <p:cNvPr id="7" name="Picture 6">
+            <a:extLst>
+              <a:ext uri="{FF2B5EF4-FFF2-40B4-BE49-F238E27FC236}">
+                <a16:creationId xmlns:a16="http://schemas.microsoft.com/office/drawing/2014/main" id="{0A9EF610-B5C0-066E-9B48-FE6D39F208EF}"/>
+              </a:ext>
+            </a:extLst>
+          </p:cNvPr>
+          <p:cNvPicPr>
+            <a:picLocks noChangeAspect="1"/>
+          </p:cNvPicPr>
+          <p:nvPr/>
+        </p:nvPicPr>
+        <p:blipFill>
+          <a:blip r:embed="rId3"/>
+          <a:stretch>
+            <a:fillRect/>
+          </a:stretch>
+        </p:blipFill>
+        <p:spPr>
+          <a:xfrm>
+            <a:off x="1366392" y="1690688"/>
+            <a:ext cx="9459216" cy="1189008"/>
+          </a:xfrm>
+          <a:prstGeom prst="rect">
+            <a:avLst/>
+          </a:prstGeom>
+          <a:ln>
+            <a:solidFill>
+              <a:schemeClr val="accent1"/>
+            </a:solidFill>
+          </a:ln>
+        </p:spPr>
+      </p:pic>
+      <p:pic>
+        <p:nvPicPr>
+          <p:cNvPr id="9" name="Picture 8">
+            <a:extLst>
+              <a:ext uri="{FF2B5EF4-FFF2-40B4-BE49-F238E27FC236}">
+                <a16:creationId xmlns:a16="http://schemas.microsoft.com/office/drawing/2014/main" id="{236DCCE5-B47D-17BE-FE8F-1537A7D28F61}"/>
+              </a:ext>
+            </a:extLst>
+          </p:cNvPr>
+          <p:cNvPicPr>
+            <a:picLocks noChangeAspect="1"/>
+          </p:cNvPicPr>
+          <p:nvPr/>
+        </p:nvPicPr>
+        <p:blipFill>
+          <a:blip r:embed="rId4"/>
+          <a:stretch>
+            <a:fillRect/>
+          </a:stretch>
+        </p:blipFill>
+        <p:spPr>
+          <a:xfrm>
+            <a:off x="2209800" y="5347157"/>
+            <a:ext cx="7772400" cy="838623"/>
+          </a:xfrm>
+          <a:prstGeom prst="rect">
+            <a:avLst/>
+          </a:prstGeom>
+          <a:ln>
+            <a:solidFill>
+              <a:schemeClr val="accent1"/>
+            </a:solidFill>
+          </a:ln>
+        </p:spPr>
+      </p:pic>
+    </p:spTree>
+    <p:extLst>
+      <p:ext uri="{BB962C8B-B14F-4D97-AF65-F5344CB8AC3E}">
+        <p14:creationId xmlns:p14="http://schemas.microsoft.com/office/powerpoint/2010/main" val="4066973122"/>
+      </p:ext>
+    </p:extLst>
+  </p:cSld>
+  <p:clrMapOvr>
+    <a:masterClrMapping/>
+  </p:clrMapOvr>
+</p:sld>
+</file>
+
+<file path=ppt/slides/slide14.xml><?xml version="1.0" encoding="utf-8"?>
+<p:sld xmlns:a="http://schemas.openxmlformats.org/drawingml/2006/main" xmlns:r="http://schemas.openxmlformats.org/officeDocument/2006/relationships" xmlns:p="http://schemas.openxmlformats.org/presentationml/2006/main">
+  <p:cSld>
+    <p:spTree>
+      <p:nvGrpSpPr>
+        <p:cNvPr id="1" name=""/>
+        <p:cNvGrpSpPr/>
+        <p:nvPr/>
+      </p:nvGrpSpPr>
+      <p:grpSpPr>
+        <a:xfrm>
+          <a:off x="0" y="0"/>
+          <a:ext cx="0" cy="0"/>
+          <a:chOff x="0" y="0"/>
+          <a:chExt cx="0" cy="0"/>
+        </a:xfrm>
+      </p:grpSpPr>
+      <p:sp>
+        <p:nvSpPr>
+          <p:cNvPr id="2" name="Title 1">
+            <a:extLst>
+              <a:ext uri="{FF2B5EF4-FFF2-40B4-BE49-F238E27FC236}">
+                <a16:creationId xmlns:a16="http://schemas.microsoft.com/office/drawing/2014/main" id="{69C67BB0-EAF3-BA60-3678-C2F45C305B85}"/>
+              </a:ext>
+            </a:extLst>
+          </p:cNvPr>
+          <p:cNvSpPr>
+            <a:spLocks noGrp="1"/>
+          </p:cNvSpPr>
+          <p:nvPr>
+            <p:ph type="title"/>
+          </p:nvPr>
+        </p:nvSpPr>
+        <p:spPr/>
+        <p:txBody>
+          <a:bodyPr/>
+          <a:lstStyle/>
+          <a:p>
+            <a:r>
+              <a:rPr lang="en-GB" dirty="0"/>
+              <a:t>Logical Operators</a:t>
+            </a:r>
+          </a:p>
+        </p:txBody>
+      </p:sp>
+      <p:sp>
+        <p:nvSpPr>
+          <p:cNvPr id="3" name="Content Placeholder 2">
+            <a:extLst>
+              <a:ext uri="{FF2B5EF4-FFF2-40B4-BE49-F238E27FC236}">
+                <a16:creationId xmlns:a16="http://schemas.microsoft.com/office/drawing/2014/main" id="{DE20A4F4-3788-4C56-4ABF-F846593AFAAD}"/>
+              </a:ext>
+            </a:extLst>
+          </p:cNvPr>
+          <p:cNvSpPr>
+            <a:spLocks noGrp="1"/>
+          </p:cNvSpPr>
+          <p:nvPr>
+            <p:ph idx="1"/>
+          </p:nvPr>
+        </p:nvSpPr>
+        <p:spPr/>
+        <p:txBody>
+          <a:bodyPr/>
+          <a:lstStyle/>
+          <a:p>
+            <a:r>
+              <a:rPr lang="en-GB" dirty="0"/>
+              <a:t>Alternatively, since finding the Paulis is easy, we can design surgery-like techniques + state injection for arbitrary gates</a:t>
+            </a:r>
+          </a:p>
+          <a:p>
+            <a:endParaRPr lang="en-GB" dirty="0"/>
+          </a:p>
+          <a:p>
+            <a:endParaRPr lang="en-GB" dirty="0"/>
+          </a:p>
+          <a:p>
+            <a:endParaRPr lang="en-GB" dirty="0"/>
+          </a:p>
+          <a:p>
+            <a:endParaRPr lang="en-GB" dirty="0"/>
+          </a:p>
+          <a:p>
+            <a:r>
+              <a:rPr lang="en-GB" dirty="0"/>
+              <a:t>However, this requires either:</a:t>
+            </a:r>
+          </a:p>
+          <a:p>
+            <a:pPr marL="914400" lvl="1" indent="-457200">
+              <a:buFont typeface="+mj-lt"/>
+              <a:buAutoNum type="arabicPeriod"/>
+            </a:pPr>
+            <a:r>
+              <a:rPr lang="en-GB" dirty="0"/>
+              <a:t>Intermediate measurements which is not supported</a:t>
+            </a:r>
+          </a:p>
+          <a:p>
+            <a:pPr marL="914400" lvl="1" indent="-457200">
+              <a:buFont typeface="+mj-lt"/>
+              <a:buAutoNum type="arabicPeriod"/>
+            </a:pPr>
+            <a:r>
+              <a:rPr lang="en-GB" dirty="0"/>
+              <a:t>Exponential blowup in post-selection</a:t>
+            </a:r>
+          </a:p>
+        </p:txBody>
+      </p:sp>
+      <p:pic>
+        <p:nvPicPr>
+          <p:cNvPr id="4" name="Picture 3">
+            <a:extLst>
+              <a:ext uri="{FF2B5EF4-FFF2-40B4-BE49-F238E27FC236}">
+                <a16:creationId xmlns:a16="http://schemas.microsoft.com/office/drawing/2014/main" id="{D104B8AD-F20C-5512-EC39-2F29198A0A85}"/>
+              </a:ext>
+            </a:extLst>
+          </p:cNvPr>
+          <p:cNvPicPr>
+            <a:picLocks noChangeAspect="1"/>
+          </p:cNvPicPr>
+          <p:nvPr/>
+        </p:nvPicPr>
+        <p:blipFill>
+          <a:blip r:embed="rId2"/>
+          <a:stretch>
+            <a:fillRect/>
+          </a:stretch>
+        </p:blipFill>
+        <p:spPr>
+          <a:xfrm>
+            <a:off x="4419600" y="2675128"/>
+            <a:ext cx="3352800" cy="2032000"/>
+          </a:xfrm>
+          <a:prstGeom prst="rect">
+            <a:avLst/>
+          </a:prstGeom>
+        </p:spPr>
+      </p:pic>
+    </p:spTree>
+    <p:extLst>
+      <p:ext uri="{BB962C8B-B14F-4D97-AF65-F5344CB8AC3E}">
+        <p14:creationId xmlns:p14="http://schemas.microsoft.com/office/powerpoint/2010/main" val="1851673599"/>
+      </p:ext>
+    </p:extLst>
+  </p:cSld>
+  <p:clrMapOvr>
+    <a:masterClrMapping/>
+  </p:clrMapOvr>
+</p:sld>
+</file>
+
+<file path=ppt/slides/slide15.xml><?xml version="1.0" encoding="utf-8"?>
+<p:sld xmlns:a="http://schemas.openxmlformats.org/drawingml/2006/main" xmlns:r="http://schemas.openxmlformats.org/officeDocument/2006/relationships" xmlns:p="http://schemas.openxmlformats.org/presentationml/2006/main">
+  <p:cSld>
+    <p:spTree>
+      <p:nvGrpSpPr>
+        <p:cNvPr id="1" name=""/>
+        <p:cNvGrpSpPr/>
+        <p:nvPr/>
+      </p:nvGrpSpPr>
+      <p:grpSpPr>
+        <a:xfrm>
+          <a:off x="0" y="0"/>
+          <a:ext cx="0" cy="0"/>
+          <a:chOff x="0" y="0"/>
+          <a:chExt cx="0" cy="0"/>
+        </a:xfrm>
+      </p:grpSpPr>
+      <p:sp>
+        <p:nvSpPr>
+          <p:cNvPr id="2" name="Title 1">
+            <a:extLst>
+              <a:ext uri="{FF2B5EF4-FFF2-40B4-BE49-F238E27FC236}">
+                <a16:creationId xmlns:a16="http://schemas.microsoft.com/office/drawing/2014/main" id="{A11D565F-8F3C-A909-7459-73673BA38968}"/>
+              </a:ext>
+            </a:extLst>
+          </p:cNvPr>
+          <p:cNvSpPr>
+            <a:spLocks noGrp="1"/>
+          </p:cNvSpPr>
+          <p:nvPr>
+            <p:ph type="title"/>
+          </p:nvPr>
+        </p:nvSpPr>
+        <p:spPr/>
+        <p:txBody>
+          <a:bodyPr/>
+          <a:lstStyle/>
+          <a:p>
+            <a:r>
+              <a:rPr lang="en-GB" dirty="0"/>
+              <a:t>What can we do instead?</a:t>
+            </a:r>
+          </a:p>
+        </p:txBody>
+      </p:sp>
+      <p:sp>
+        <p:nvSpPr>
+          <p:cNvPr id="3" name="Content Placeholder 2">
+            <a:extLst>
+              <a:ext uri="{FF2B5EF4-FFF2-40B4-BE49-F238E27FC236}">
+                <a16:creationId xmlns:a16="http://schemas.microsoft.com/office/drawing/2014/main" id="{A50B5148-E552-5F79-5F05-BDA735694EE0}"/>
+              </a:ext>
+            </a:extLst>
+          </p:cNvPr>
+          <p:cNvSpPr>
+            <a:spLocks noGrp="1"/>
+          </p:cNvSpPr>
+          <p:nvPr>
+            <p:ph idx="1"/>
+          </p:nvPr>
+        </p:nvSpPr>
+        <p:spPr/>
+        <p:txBody>
+          <a:bodyPr/>
+          <a:lstStyle/>
+          <a:p>
+            <a:r>
+              <a:rPr lang="en-GB" dirty="0"/>
+              <a:t>When trying to find logical </a:t>
+            </a:r>
+            <a:r>
+              <a:rPr lang="en-GB" dirty="0" err="1"/>
+              <a:t>Cliffords</a:t>
+            </a:r>
+            <a:r>
+              <a:rPr lang="en-GB" dirty="0"/>
+              <a:t>, we can restrict ourselves to only Clifford operations</a:t>
+            </a:r>
+          </a:p>
+          <a:p>
+            <a:endParaRPr lang="en-GB" dirty="0"/>
+          </a:p>
+          <a:p>
+            <a:r>
+              <a:rPr lang="en-GB" dirty="0"/>
+              <a:t>For now, we can ignore FT and just find logical operations</a:t>
+            </a:r>
+          </a:p>
+          <a:p>
+            <a:endParaRPr lang="en-GB" dirty="0"/>
+          </a:p>
+          <a:p>
+            <a:r>
+              <a:rPr lang="en-GB" dirty="0"/>
+              <a:t>This is still exponential, but the search space will be discrete so it should work for smaller [[n, k, d]]</a:t>
+            </a:r>
+          </a:p>
+        </p:txBody>
+      </p:sp>
+    </p:spTree>
+    <p:extLst>
+      <p:ext uri="{BB962C8B-B14F-4D97-AF65-F5344CB8AC3E}">
+        <p14:creationId xmlns:p14="http://schemas.microsoft.com/office/powerpoint/2010/main" val="2365756027"/>
+      </p:ext>
+    </p:extLst>
+  </p:cSld>
+  <p:clrMapOvr>
+    <a:masterClrMapping/>
+  </p:clrMapOvr>
+</p:sld>
+</file>
+
+<file path=ppt/slides/slide16.xml><?xml version="1.0" encoding="utf-8"?>
+<p:sld xmlns:a="http://schemas.openxmlformats.org/drawingml/2006/main" xmlns:r="http://schemas.openxmlformats.org/officeDocument/2006/relationships" xmlns:p="http://schemas.openxmlformats.org/presentationml/2006/main">
+  <p:cSld>
+    <p:spTree>
+      <p:nvGrpSpPr>
+        <p:cNvPr id="1" name=""/>
+        <p:cNvGrpSpPr/>
+        <p:nvPr/>
+      </p:nvGrpSpPr>
+      <p:grpSpPr>
+        <a:xfrm>
+          <a:off x="0" y="0"/>
+          <a:ext cx="0" cy="0"/>
+          <a:chOff x="0" y="0"/>
+          <a:chExt cx="0" cy="0"/>
+        </a:xfrm>
+      </p:grpSpPr>
+      <p:sp>
+        <p:nvSpPr>
+          <p:cNvPr id="2" name="Title 1">
+            <a:extLst>
+              <a:ext uri="{FF2B5EF4-FFF2-40B4-BE49-F238E27FC236}">
+                <a16:creationId xmlns:a16="http://schemas.microsoft.com/office/drawing/2014/main" id="{F9077B86-8B52-35ED-64AD-24BF3FB1391F}"/>
+              </a:ext>
+            </a:extLst>
+          </p:cNvPr>
+          <p:cNvSpPr>
+            <a:spLocks noGrp="1"/>
+          </p:cNvSpPr>
+          <p:nvPr>
+            <p:ph type="title"/>
+          </p:nvPr>
+        </p:nvSpPr>
+        <p:spPr/>
+        <p:txBody>
+          <a:bodyPr/>
+          <a:lstStyle/>
+          <a:p>
+            <a:r>
+              <a:rPr lang="en-GB" dirty="0"/>
+              <a:t>Resources and Questions</a:t>
+            </a:r>
+          </a:p>
+        </p:txBody>
+      </p:sp>
+      <p:sp>
+        <p:nvSpPr>
+          <p:cNvPr id="3" name="Content Placeholder 2">
+            <a:extLst>
+              <a:ext uri="{FF2B5EF4-FFF2-40B4-BE49-F238E27FC236}">
+                <a16:creationId xmlns:a16="http://schemas.microsoft.com/office/drawing/2014/main" id="{6632D4D4-86CE-3321-0761-ABCEEF2CEF05}"/>
+              </a:ext>
+            </a:extLst>
+          </p:cNvPr>
+          <p:cNvSpPr>
+            <a:spLocks noGrp="1"/>
+          </p:cNvSpPr>
+          <p:nvPr>
+            <p:ph idx="1"/>
+          </p:nvPr>
+        </p:nvSpPr>
+        <p:spPr/>
+        <p:txBody>
+          <a:bodyPr/>
+          <a:lstStyle/>
+          <a:p>
+            <a:r>
+              <a:rPr lang="en-GB" dirty="0"/>
+              <a:t>Generalized Shor’s for any n:</a:t>
+            </a:r>
+          </a:p>
+          <a:p>
+            <a:pPr lvl="1"/>
+            <a:r>
+              <a:rPr lang="en-GB" dirty="0"/>
+              <a:t>How does it work?</a:t>
+            </a:r>
+          </a:p>
+          <a:p>
+            <a:pPr lvl="1"/>
+            <a:r>
+              <a:rPr lang="en-GB" dirty="0"/>
+              <a:t>Examples?</a:t>
+            </a:r>
+          </a:p>
+          <a:p>
+            <a:endParaRPr lang="en-GB" dirty="0"/>
+          </a:p>
+          <a:p>
+            <a:r>
+              <a:rPr lang="en-GB" dirty="0"/>
+              <a:t>Error model?</a:t>
+            </a:r>
+          </a:p>
+          <a:p>
+            <a:pPr lvl="1"/>
+            <a:r>
+              <a:rPr lang="en-GB" dirty="0"/>
+              <a:t>If we can simulate the error properties, should be possible to guide our search to minimize errors despite being non-FT</a:t>
+            </a:r>
+          </a:p>
+          <a:p>
+            <a:pPr lvl="1"/>
+            <a:r>
+              <a:rPr lang="en-GB" dirty="0"/>
+              <a:t>Is it enough to minimize 2-qubit gates?</a:t>
+            </a:r>
+          </a:p>
+        </p:txBody>
+      </p:sp>
+    </p:spTree>
+    <p:extLst>
+      <p:ext uri="{BB962C8B-B14F-4D97-AF65-F5344CB8AC3E}">
+        <p14:creationId xmlns:p14="http://schemas.microsoft.com/office/powerpoint/2010/main" val="2820038892"/>
+      </p:ext>
+    </p:extLst>
+  </p:cSld>
+  <p:clrMapOvr>
+    <a:masterClrMapping/>
+  </p:clrMapOvr>
+</p:sld>
+</file>
+
+<file path=ppt/slides/slide17.xml><?xml version="1.0" encoding="utf-8"?>
+<p:sld xmlns:a="http://schemas.openxmlformats.org/drawingml/2006/main" xmlns:r="http://schemas.openxmlformats.org/officeDocument/2006/relationships" xmlns:p="http://schemas.openxmlformats.org/presentationml/2006/main">
+  <p:cSld>
+    <p:spTree>
+      <p:nvGrpSpPr>
+        <p:cNvPr id="1" name=""/>
+        <p:cNvGrpSpPr/>
+        <p:nvPr/>
+      </p:nvGrpSpPr>
+      <p:grpSpPr>
+        <a:xfrm>
+          <a:off x="0" y="0"/>
+          <a:ext cx="0" cy="0"/>
+          <a:chOff x="0" y="0"/>
+          <a:chExt cx="0" cy="0"/>
+        </a:xfrm>
+      </p:grpSpPr>
+      <p:sp>
+        <p:nvSpPr>
+          <p:cNvPr id="2" name="Title 1">
+            <a:extLst>
+              <a:ext uri="{FF2B5EF4-FFF2-40B4-BE49-F238E27FC236}">
+                <a16:creationId xmlns:a16="http://schemas.microsoft.com/office/drawing/2014/main" id="{55C2E67F-2AAA-F67E-7163-A6622B052162}"/>
+              </a:ext>
+            </a:extLst>
+          </p:cNvPr>
+          <p:cNvSpPr>
+            <a:spLocks noGrp="1"/>
+          </p:cNvSpPr>
+          <p:nvPr>
+            <p:ph type="title"/>
+          </p:nvPr>
+        </p:nvSpPr>
+        <p:spPr>
+          <a:xfrm>
+            <a:off x="838200" y="365125"/>
+            <a:ext cx="10515600" cy="890651"/>
+          </a:xfrm>
+        </p:spPr>
+        <p:txBody>
+          <a:bodyPr/>
+          <a:lstStyle/>
+          <a:p>
+            <a:r>
+              <a:rPr lang="en-GB" dirty="0"/>
+              <a:t>Shor’s Algorithm Circuit for N = 15, a = 2</a:t>
+            </a:r>
+          </a:p>
+        </p:txBody>
+      </p:sp>
+      <p:sp>
+        <p:nvSpPr>
+          <p:cNvPr id="3" name="Content Placeholder 2">
+            <a:extLst>
+              <a:ext uri="{FF2B5EF4-FFF2-40B4-BE49-F238E27FC236}">
+                <a16:creationId xmlns:a16="http://schemas.microsoft.com/office/drawing/2014/main" id="{DD3CF801-3C6F-BFCF-12EB-D10D5E9BE3FD}"/>
+              </a:ext>
+            </a:extLst>
+          </p:cNvPr>
+          <p:cNvSpPr>
+            <a:spLocks noGrp="1"/>
+          </p:cNvSpPr>
+          <p:nvPr>
+            <p:ph idx="1"/>
+          </p:nvPr>
+        </p:nvSpPr>
+        <p:spPr>
+          <a:xfrm>
+            <a:off x="838200" y="1566672"/>
+            <a:ext cx="10515600" cy="5291327"/>
+          </a:xfrm>
+        </p:spPr>
+        <p:txBody>
+          <a:bodyPr>
+            <a:normAutofit/>
+          </a:bodyPr>
+          <a:lstStyle/>
+          <a:p>
+            <a:r>
+              <a:rPr lang="en-GB" dirty="0"/>
+              <a:t>Circuit is slightly optimized by ignoring the first step of the oracle</a:t>
+            </a:r>
+          </a:p>
+        </p:txBody>
+      </p:sp>
+      <p:pic>
+        <p:nvPicPr>
+          <p:cNvPr id="4" name="Picture 3">
+            <a:extLst>
+              <a:ext uri="{FF2B5EF4-FFF2-40B4-BE49-F238E27FC236}">
+                <a16:creationId xmlns:a16="http://schemas.microsoft.com/office/drawing/2014/main" id="{2F217F04-727F-15E5-E05D-3059348D59FB}"/>
+              </a:ext>
+            </a:extLst>
+          </p:cNvPr>
+          <p:cNvPicPr>
+            <a:picLocks noChangeAspect="1"/>
+          </p:cNvPicPr>
+          <p:nvPr/>
+        </p:nvPicPr>
+        <p:blipFill>
+          <a:blip r:embed="rId2"/>
+          <a:stretch>
+            <a:fillRect/>
+          </a:stretch>
+        </p:blipFill>
+        <p:spPr>
+          <a:xfrm>
+            <a:off x="148590" y="2510535"/>
+            <a:ext cx="6286500" cy="3403600"/>
+          </a:xfrm>
+          <a:prstGeom prst="rect">
+            <a:avLst/>
+          </a:prstGeom>
+        </p:spPr>
+      </p:pic>
+      <p:pic>
+        <p:nvPicPr>
+          <p:cNvPr id="5" name="Picture 4">
+            <a:extLst>
+              <a:ext uri="{FF2B5EF4-FFF2-40B4-BE49-F238E27FC236}">
+                <a16:creationId xmlns:a16="http://schemas.microsoft.com/office/drawing/2014/main" id="{54BFC87C-4A94-688B-C2A1-DEB15740CC51}"/>
+              </a:ext>
+            </a:extLst>
+          </p:cNvPr>
+          <p:cNvPicPr>
+            <a:picLocks noChangeAspect="1"/>
+          </p:cNvPicPr>
+          <p:nvPr/>
+        </p:nvPicPr>
+        <p:blipFill>
+          <a:blip r:embed="rId3"/>
+          <a:stretch>
+            <a:fillRect/>
+          </a:stretch>
+        </p:blipFill>
+        <p:spPr>
+          <a:xfrm>
+            <a:off x="7124700" y="2510535"/>
+            <a:ext cx="4167467" cy="3262121"/>
+          </a:xfrm>
+          <a:prstGeom prst="rect">
+            <a:avLst/>
+          </a:prstGeom>
+        </p:spPr>
+      </p:pic>
+    </p:spTree>
+    <p:extLst>
+      <p:ext uri="{BB962C8B-B14F-4D97-AF65-F5344CB8AC3E}">
+        <p14:creationId xmlns:p14="http://schemas.microsoft.com/office/powerpoint/2010/main" val="2452992976"/>
+      </p:ext>
+    </p:extLst>
+  </p:cSld>
+  <p:clrMapOvr>
+    <a:masterClrMapping/>
+  </p:clrMapOvr>
+</p:sld>
+</file>
+
+<file path=ppt/slides/slide18.xml><?xml version="1.0" encoding="utf-8"?>
+<p:sld xmlns:a="http://schemas.openxmlformats.org/drawingml/2006/main" xmlns:r="http://schemas.openxmlformats.org/officeDocument/2006/relationships" xmlns:p="http://schemas.openxmlformats.org/presentationml/2006/main">
+  <p:cSld>
+    <p:spTree>
+      <p:nvGrpSpPr>
+        <p:cNvPr id="1" name=""/>
+        <p:cNvGrpSpPr/>
+        <p:nvPr/>
+      </p:nvGrpSpPr>
+      <p:grpSpPr>
+        <a:xfrm>
+          <a:off x="0" y="0"/>
+          <a:ext cx="0" cy="0"/>
+          <a:chOff x="0" y="0"/>
+          <a:chExt cx="0" cy="0"/>
+        </a:xfrm>
+      </p:grpSpPr>
+      <p:sp>
+        <p:nvSpPr>
+          <p:cNvPr id="2" name="Title 1">
+            <a:extLst>
+              <a:ext uri="{FF2B5EF4-FFF2-40B4-BE49-F238E27FC236}">
+                <a16:creationId xmlns:a16="http://schemas.microsoft.com/office/drawing/2014/main" id="{225F0F42-D94E-4330-7E74-95CFE13A6367}"/>
+              </a:ext>
+            </a:extLst>
+          </p:cNvPr>
+          <p:cNvSpPr>
+            <a:spLocks noGrp="1"/>
+          </p:cNvSpPr>
+          <p:nvPr>
+            <p:ph type="title"/>
+          </p:nvPr>
+        </p:nvSpPr>
+        <p:spPr/>
+        <p:txBody>
+          <a:bodyPr/>
+          <a:lstStyle/>
+          <a:p>
+            <a:r>
+              <a:rPr lang="en-GB" dirty="0"/>
+              <a:t>Shor’s Algorithm Circuit for N = 15, a = 2</a:t>
+            </a:r>
+          </a:p>
+        </p:txBody>
+      </p:sp>
+      <p:sp>
+        <p:nvSpPr>
+          <p:cNvPr id="3" name="Content Placeholder 2">
+            <a:extLst>
+              <a:ext uri="{FF2B5EF4-FFF2-40B4-BE49-F238E27FC236}">
+                <a16:creationId xmlns:a16="http://schemas.microsoft.com/office/drawing/2014/main" id="{CC338C6E-40D4-2D7A-4BD0-C11BC7797408}"/>
+              </a:ext>
+            </a:extLst>
+          </p:cNvPr>
+          <p:cNvSpPr>
+            <a:spLocks noGrp="1"/>
+          </p:cNvSpPr>
+          <p:nvPr>
+            <p:ph idx="1"/>
+          </p:nvPr>
+        </p:nvSpPr>
+        <p:spPr/>
+        <p:txBody>
+          <a:bodyPr/>
+          <a:lstStyle/>
+          <a:p>
+            <a:r>
+              <a:rPr lang="en-GB" dirty="0"/>
+              <a:t>Compiling this to the “</a:t>
+            </a:r>
+            <a:r>
+              <a:rPr lang="en-GB" dirty="0" err="1"/>
+              <a:t>CZTargetGateset</a:t>
+            </a:r>
+            <a:r>
+              <a:rPr lang="en-GB" dirty="0"/>
+              <a:t>” (</a:t>
+            </a:r>
+            <a:r>
+              <a:rPr lang="en-GB" dirty="0" err="1"/>
+              <a:t>cirq</a:t>
+            </a:r>
+            <a:r>
+              <a:rPr lang="en-GB" dirty="0"/>
+              <a:t>) gives a depth of 59.</a:t>
+            </a:r>
+          </a:p>
+          <a:p>
+            <a:endParaRPr lang="en-GB" dirty="0"/>
+          </a:p>
+          <a:p>
+            <a:r>
+              <a:rPr lang="en-GB" dirty="0"/>
+              <a:t>This </a:t>
+            </a:r>
+            <a:r>
+              <a:rPr lang="en-GB" dirty="0" err="1"/>
+              <a:t>gateset</a:t>
+            </a:r>
+            <a:r>
+              <a:rPr lang="en-GB" dirty="0"/>
+              <a:t> has GR gates, CZ gates and </a:t>
+            </a:r>
+            <a:r>
+              <a:rPr lang="en-GB" dirty="0" err="1"/>
+              <a:t>PhaseXZ</a:t>
+            </a:r>
+            <a:r>
+              <a:rPr lang="en-GB" dirty="0"/>
+              <a:t> gates</a:t>
+            </a:r>
+          </a:p>
+          <a:p>
+            <a:pPr lvl="1"/>
+            <a:r>
+              <a:rPr lang="en-GB" dirty="0"/>
+              <a:t>This is still more generic than what is supported</a:t>
+            </a:r>
+          </a:p>
+          <a:p>
+            <a:endParaRPr lang="en-GB" dirty="0"/>
+          </a:p>
+          <a:p>
+            <a:r>
+              <a:rPr lang="en-GB" dirty="0"/>
+              <a:t>If we disallow parallel gate execution, the depth goes up to ~90.</a:t>
+            </a:r>
+          </a:p>
+        </p:txBody>
+      </p:sp>
+    </p:spTree>
+    <p:extLst>
+      <p:ext uri="{BB962C8B-B14F-4D97-AF65-F5344CB8AC3E}">
+        <p14:creationId xmlns:p14="http://schemas.microsoft.com/office/powerpoint/2010/main" val="3116380619"/>
+      </p:ext>
+    </p:extLst>
+  </p:cSld>
+  <p:clrMapOvr>
+    <a:masterClrMapping/>
+  </p:clrMapOvr>
+</p:sld>
+</file>
+
+<file path=ppt/slides/slide19.xml><?xml version="1.0" encoding="utf-8"?>
+<p:sld xmlns:a="http://schemas.openxmlformats.org/drawingml/2006/main" xmlns:r="http://schemas.openxmlformats.org/officeDocument/2006/relationships" xmlns:p="http://schemas.openxmlformats.org/presentationml/2006/main">
+  <p:cSld>
+    <p:spTree>
+      <p:nvGrpSpPr>
+        <p:cNvPr id="1" name=""/>
+        <p:cNvGrpSpPr/>
+        <p:nvPr/>
+      </p:nvGrpSpPr>
+      <p:grpSpPr>
+        <a:xfrm>
+          <a:off x="0" y="0"/>
+          <a:ext cx="0" cy="0"/>
+          <a:chOff x="0" y="0"/>
+          <a:chExt cx="0" cy="0"/>
+        </a:xfrm>
+      </p:grpSpPr>
+      <p:sp>
+        <p:nvSpPr>
+          <p:cNvPr id="2" name="Title 1">
+            <a:extLst>
+              <a:ext uri="{FF2B5EF4-FFF2-40B4-BE49-F238E27FC236}">
+                <a16:creationId xmlns:a16="http://schemas.microsoft.com/office/drawing/2014/main" id="{8ED076E4-E1B4-E9E5-5F6E-5E6F1C5FCA0D}"/>
+              </a:ext>
+            </a:extLst>
+          </p:cNvPr>
+          <p:cNvSpPr>
+            <a:spLocks noGrp="1"/>
+          </p:cNvSpPr>
+          <p:nvPr>
+            <p:ph type="title"/>
+          </p:nvPr>
+        </p:nvSpPr>
+        <p:spPr/>
+        <p:txBody>
+          <a:bodyPr/>
+          <a:lstStyle/>
+          <a:p>
+            <a:r>
+              <a:rPr lang="en-GB" dirty="0"/>
+              <a:t>Shor’s Algorithm Circuit for N = 15, a = 2</a:t>
+            </a:r>
+          </a:p>
+        </p:txBody>
+      </p:sp>
+      <p:sp>
+        <p:nvSpPr>
+          <p:cNvPr id="3" name="Content Placeholder 2">
+            <a:extLst>
+              <a:ext uri="{FF2B5EF4-FFF2-40B4-BE49-F238E27FC236}">
+                <a16:creationId xmlns:a16="http://schemas.microsoft.com/office/drawing/2014/main" id="{559FB92F-91F0-BAF2-66AD-95C9B67EED05}"/>
+              </a:ext>
+            </a:extLst>
+          </p:cNvPr>
+          <p:cNvSpPr>
+            <a:spLocks noGrp="1"/>
+          </p:cNvSpPr>
+          <p:nvPr>
+            <p:ph idx="1"/>
+          </p:nvPr>
+        </p:nvSpPr>
+        <p:spPr/>
+        <p:txBody>
+          <a:bodyPr/>
+          <a:lstStyle/>
+          <a:p>
+            <a:r>
+              <a:rPr lang="en-GB" dirty="0"/>
+              <a:t>Since we have 6 qubits in the circuit, we first start with the [[8, 6, 2]] code to analyse the depth/operations needed</a:t>
+            </a:r>
+          </a:p>
+          <a:p>
+            <a:r>
+              <a:rPr lang="en-GB" dirty="0"/>
+              <a:t>The </a:t>
+            </a:r>
+            <a:r>
+              <a:rPr lang="en-GB" dirty="0" err="1"/>
+              <a:t>codeqraft</a:t>
+            </a:r>
+            <a:r>
+              <a:rPr lang="en-GB" dirty="0"/>
+              <a:t> compiler required making an API call and the compiler wasn’t open-source</a:t>
+            </a:r>
+          </a:p>
+        </p:txBody>
+      </p:sp>
+      <p:pic>
+        <p:nvPicPr>
+          <p:cNvPr id="5" name="Picture 4">
+            <a:extLst>
+              <a:ext uri="{FF2B5EF4-FFF2-40B4-BE49-F238E27FC236}">
+                <a16:creationId xmlns:a16="http://schemas.microsoft.com/office/drawing/2014/main" id="{E7FBA3CF-F7DA-587F-0D5E-F4C9FCE3BBBD}"/>
+              </a:ext>
+            </a:extLst>
+          </p:cNvPr>
+          <p:cNvPicPr>
+            <a:picLocks noChangeAspect="1"/>
+          </p:cNvPicPr>
+          <p:nvPr/>
+        </p:nvPicPr>
+        <p:blipFill>
+          <a:blip r:embed="rId2"/>
+          <a:stretch>
+            <a:fillRect/>
+          </a:stretch>
+        </p:blipFill>
+        <p:spPr>
+          <a:xfrm>
+            <a:off x="3009900" y="3673602"/>
+            <a:ext cx="6172200" cy="3009900"/>
+          </a:xfrm>
+          <a:prstGeom prst="rect">
+            <a:avLst/>
+          </a:prstGeom>
+        </p:spPr>
+      </p:pic>
+    </p:spTree>
+    <p:extLst>
+      <p:ext uri="{BB962C8B-B14F-4D97-AF65-F5344CB8AC3E}">
+        <p14:creationId xmlns:p14="http://schemas.microsoft.com/office/powerpoint/2010/main" val="2525640139"/>
+      </p:ext>
+    </p:extLst>
+  </p:cSld>
+  <p:clrMapOvr>
+    <a:masterClrMapping/>
+  </p:clrMapOvr>
+</p:sld>
+</file>
+
 <file path=ppt/slides/slide2.xml><?xml version="1.0" encoding="utf-8"?>
 <p:sld xmlns:a="http://schemas.openxmlformats.org/drawingml/2006/main" xmlns:r="http://schemas.openxmlformats.org/officeDocument/2006/relationships" xmlns:p="http://schemas.openxmlformats.org/presentationml/2006/main">
   <p:cSld>
@@ -4111,6 +5348,358 @@
     <p:extLst>
       <p:ext uri="{BB962C8B-B14F-4D97-AF65-F5344CB8AC3E}">
         <p14:creationId xmlns:p14="http://schemas.microsoft.com/office/powerpoint/2010/main" val="2175014878"/>
+      </p:ext>
+    </p:extLst>
+  </p:cSld>
+  <p:clrMapOvr>
+    <a:masterClrMapping/>
+  </p:clrMapOvr>
+</p:sld>
+</file>
+
+<file path=ppt/slides/slide20.xml><?xml version="1.0" encoding="utf-8"?>
+<p:sld xmlns:a="http://schemas.openxmlformats.org/drawingml/2006/main" xmlns:r="http://schemas.openxmlformats.org/officeDocument/2006/relationships" xmlns:p="http://schemas.openxmlformats.org/presentationml/2006/main">
+  <p:cSld>
+    <p:spTree>
+      <p:nvGrpSpPr>
+        <p:cNvPr id="1" name=""/>
+        <p:cNvGrpSpPr/>
+        <p:nvPr/>
+      </p:nvGrpSpPr>
+      <p:grpSpPr>
+        <a:xfrm>
+          <a:off x="0" y="0"/>
+          <a:ext cx="0" cy="0"/>
+          <a:chOff x="0" y="0"/>
+          <a:chExt cx="0" cy="0"/>
+        </a:xfrm>
+      </p:grpSpPr>
+      <p:sp>
+        <p:nvSpPr>
+          <p:cNvPr id="2" name="Title 1">
+            <a:extLst>
+              <a:ext uri="{FF2B5EF4-FFF2-40B4-BE49-F238E27FC236}">
+                <a16:creationId xmlns:a16="http://schemas.microsoft.com/office/drawing/2014/main" id="{E8140116-D45D-D99C-0BC1-F7819BD1DF5F}"/>
+              </a:ext>
+            </a:extLst>
+          </p:cNvPr>
+          <p:cNvSpPr>
+            <a:spLocks noGrp="1"/>
+          </p:cNvSpPr>
+          <p:nvPr>
+            <p:ph type="title"/>
+          </p:nvPr>
+        </p:nvSpPr>
+        <p:spPr/>
+        <p:txBody>
+          <a:bodyPr/>
+          <a:lstStyle/>
+          <a:p>
+            <a:r>
+              <a:rPr lang="en-GB" dirty="0"/>
+              <a:t>Compilation to [[8, 6, 2]] Code</a:t>
+            </a:r>
+          </a:p>
+        </p:txBody>
+      </p:sp>
+      <p:sp>
+        <p:nvSpPr>
+          <p:cNvPr id="3" name="Content Placeholder 2">
+            <a:extLst>
+              <a:ext uri="{FF2B5EF4-FFF2-40B4-BE49-F238E27FC236}">
+                <a16:creationId xmlns:a16="http://schemas.microsoft.com/office/drawing/2014/main" id="{C033ED41-127A-CA8C-CDAC-DA46D4C5A713}"/>
+              </a:ext>
+            </a:extLst>
+          </p:cNvPr>
+          <p:cNvSpPr>
+            <a:spLocks noGrp="1"/>
+          </p:cNvSpPr>
+          <p:nvPr>
+            <p:ph idx="1"/>
+          </p:nvPr>
+        </p:nvSpPr>
+        <p:spPr/>
+        <p:txBody>
+          <a:bodyPr/>
+          <a:lstStyle/>
+          <a:p>
+            <a:r>
+              <a:rPr lang="en-GB" dirty="0"/>
+              <a:t>Ignoring FT and assuming all-to-all connectivity, we get a circuit with 686 gates (on compilation with </a:t>
+            </a:r>
+            <a:r>
+              <a:rPr lang="en-GB" dirty="0" err="1"/>
+              <a:t>superstaq</a:t>
+            </a:r>
+            <a:r>
+              <a:rPr lang="en-GB" dirty="0"/>
+              <a:t>).</a:t>
+            </a:r>
+          </a:p>
+          <a:p>
+            <a:endParaRPr lang="en-GB" dirty="0"/>
+          </a:p>
+          <a:p>
+            <a:r>
+              <a:rPr lang="en-GB" dirty="0"/>
+              <a:t>Out of this, 219 are CZ, 254 are GR and 213 are Rz gates.</a:t>
+            </a:r>
+          </a:p>
+        </p:txBody>
+      </p:sp>
+    </p:spTree>
+    <p:extLst>
+      <p:ext uri="{BB962C8B-B14F-4D97-AF65-F5344CB8AC3E}">
+        <p14:creationId xmlns:p14="http://schemas.microsoft.com/office/powerpoint/2010/main" val="2114031840"/>
+      </p:ext>
+    </p:extLst>
+  </p:cSld>
+  <p:clrMapOvr>
+    <a:masterClrMapping/>
+  </p:clrMapOvr>
+</p:sld>
+</file>
+
+<file path=ppt/slides/slide21.xml><?xml version="1.0" encoding="utf-8"?>
+<p:sld xmlns:a="http://schemas.openxmlformats.org/drawingml/2006/main" xmlns:r="http://schemas.openxmlformats.org/officeDocument/2006/relationships" xmlns:p="http://schemas.openxmlformats.org/presentationml/2006/main">
+  <p:cSld>
+    <p:spTree>
+      <p:nvGrpSpPr>
+        <p:cNvPr id="1" name=""/>
+        <p:cNvGrpSpPr/>
+        <p:nvPr/>
+      </p:nvGrpSpPr>
+      <p:grpSpPr>
+        <a:xfrm>
+          <a:off x="0" y="0"/>
+          <a:ext cx="0" cy="0"/>
+          <a:chOff x="0" y="0"/>
+          <a:chExt cx="0" cy="0"/>
+        </a:xfrm>
+      </p:grpSpPr>
+      <p:sp>
+        <p:nvSpPr>
+          <p:cNvPr id="2" name="Title 1">
+            <a:extLst>
+              <a:ext uri="{FF2B5EF4-FFF2-40B4-BE49-F238E27FC236}">
+                <a16:creationId xmlns:a16="http://schemas.microsoft.com/office/drawing/2014/main" id="{48C5F4C2-CE3D-E9AC-878B-FD32740A8619}"/>
+              </a:ext>
+            </a:extLst>
+          </p:cNvPr>
+          <p:cNvSpPr>
+            <a:spLocks noGrp="1"/>
+          </p:cNvSpPr>
+          <p:nvPr>
+            <p:ph type="title"/>
+          </p:nvPr>
+        </p:nvSpPr>
+        <p:spPr/>
+        <p:txBody>
+          <a:bodyPr/>
+          <a:lstStyle/>
+          <a:p>
+            <a:r>
+              <a:rPr lang="en-GB" dirty="0"/>
+              <a:t>Caveats</a:t>
+            </a:r>
+          </a:p>
+        </p:txBody>
+      </p:sp>
+      <p:sp>
+        <p:nvSpPr>
+          <p:cNvPr id="3" name="Content Placeholder 2">
+            <a:extLst>
+              <a:ext uri="{FF2B5EF4-FFF2-40B4-BE49-F238E27FC236}">
+                <a16:creationId xmlns:a16="http://schemas.microsoft.com/office/drawing/2014/main" id="{3D71B0A9-31F1-106E-6C00-F0E67D3F37B2}"/>
+              </a:ext>
+            </a:extLst>
+          </p:cNvPr>
+          <p:cNvSpPr>
+            <a:spLocks noGrp="1"/>
+          </p:cNvSpPr>
+          <p:nvPr>
+            <p:ph idx="1"/>
+          </p:nvPr>
+        </p:nvSpPr>
+        <p:spPr/>
+        <p:txBody>
+          <a:bodyPr/>
+          <a:lstStyle/>
+          <a:p>
+            <a:r>
+              <a:rPr lang="en-GB" dirty="0"/>
+              <a:t>All-to-all connectivity assumption</a:t>
+            </a:r>
+          </a:p>
+          <a:p>
+            <a:endParaRPr lang="en-GB" dirty="0"/>
+          </a:p>
+          <a:p>
+            <a:r>
+              <a:rPr lang="en-GB" dirty="0"/>
+              <a:t>Sub-optimal compilation pipeline (</a:t>
+            </a:r>
+            <a:r>
+              <a:rPr lang="en-GB" dirty="0" err="1"/>
+              <a:t>superstaq</a:t>
+            </a:r>
+            <a:r>
+              <a:rPr lang="en-GB" dirty="0"/>
+              <a:t> &lt;-&gt; </a:t>
+            </a:r>
+            <a:r>
+              <a:rPr lang="en-GB" dirty="0" err="1"/>
+              <a:t>cirq</a:t>
+            </a:r>
+            <a:r>
+              <a:rPr lang="en-GB" dirty="0"/>
+              <a:t> &lt;-&gt; qiskit)</a:t>
+            </a:r>
+          </a:p>
+          <a:p>
+            <a:endParaRPr lang="en-GB" dirty="0"/>
+          </a:p>
+          <a:p>
+            <a:r>
+              <a:rPr lang="en-GB" dirty="0"/>
+              <a:t>Would it be possible to get access to the non-free trial of </a:t>
+            </a:r>
+            <a:r>
+              <a:rPr lang="en-GB" dirty="0" err="1"/>
+              <a:t>superstaq</a:t>
+            </a:r>
+            <a:r>
+              <a:rPr lang="en-GB" dirty="0"/>
+              <a:t>?</a:t>
+            </a:r>
+          </a:p>
+          <a:p>
+            <a:endParaRPr lang="en-GB" dirty="0"/>
+          </a:p>
+          <a:p>
+            <a:r>
+              <a:rPr lang="en-GB" dirty="0"/>
+              <a:t>Suggestions for optimal compilation pipeline are welcome</a:t>
+            </a:r>
+          </a:p>
+        </p:txBody>
+      </p:sp>
+    </p:spTree>
+    <p:extLst>
+      <p:ext uri="{BB962C8B-B14F-4D97-AF65-F5344CB8AC3E}">
+        <p14:creationId xmlns:p14="http://schemas.microsoft.com/office/powerpoint/2010/main" val="3414261942"/>
+      </p:ext>
+    </p:extLst>
+  </p:cSld>
+  <p:clrMapOvr>
+    <a:masterClrMapping/>
+  </p:clrMapOvr>
+</p:sld>
+</file>
+
+<file path=ppt/slides/slide22.xml><?xml version="1.0" encoding="utf-8"?>
+<p:sld xmlns:a="http://schemas.openxmlformats.org/drawingml/2006/main" xmlns:r="http://schemas.openxmlformats.org/officeDocument/2006/relationships" xmlns:p="http://schemas.openxmlformats.org/presentationml/2006/main">
+  <p:cSld>
+    <p:spTree>
+      <p:nvGrpSpPr>
+        <p:cNvPr id="1" name=""/>
+        <p:cNvGrpSpPr/>
+        <p:nvPr/>
+      </p:nvGrpSpPr>
+      <p:grpSpPr>
+        <a:xfrm>
+          <a:off x="0" y="0"/>
+          <a:ext cx="0" cy="0"/>
+          <a:chOff x="0" y="0"/>
+          <a:chExt cx="0" cy="0"/>
+        </a:xfrm>
+      </p:grpSpPr>
+      <p:sp>
+        <p:nvSpPr>
+          <p:cNvPr id="2" name="Title 1">
+            <a:extLst>
+              <a:ext uri="{FF2B5EF4-FFF2-40B4-BE49-F238E27FC236}">
+                <a16:creationId xmlns:a16="http://schemas.microsoft.com/office/drawing/2014/main" id="{15EADAAA-30D4-9EDE-86C6-0E2238065AA9}"/>
+              </a:ext>
+            </a:extLst>
+          </p:cNvPr>
+          <p:cNvSpPr>
+            <a:spLocks noGrp="1"/>
+          </p:cNvSpPr>
+          <p:nvPr>
+            <p:ph type="title"/>
+          </p:nvPr>
+        </p:nvSpPr>
+        <p:spPr/>
+        <p:txBody>
+          <a:bodyPr/>
+          <a:lstStyle/>
+          <a:p>
+            <a:r>
+              <a:rPr lang="en-GB" dirty="0"/>
+              <a:t>Next Steps</a:t>
+            </a:r>
+          </a:p>
+        </p:txBody>
+      </p:sp>
+      <p:sp>
+        <p:nvSpPr>
+          <p:cNvPr id="3" name="Content Placeholder 2">
+            <a:extLst>
+              <a:ext uri="{FF2B5EF4-FFF2-40B4-BE49-F238E27FC236}">
+                <a16:creationId xmlns:a16="http://schemas.microsoft.com/office/drawing/2014/main" id="{F35096DD-B522-7C62-C3B7-8A29B6F78D29}"/>
+              </a:ext>
+            </a:extLst>
+          </p:cNvPr>
+          <p:cNvSpPr>
+            <a:spLocks noGrp="1"/>
+          </p:cNvSpPr>
+          <p:nvPr>
+            <p:ph idx="1"/>
+          </p:nvPr>
+        </p:nvSpPr>
+        <p:spPr/>
+        <p:txBody>
+          <a:bodyPr/>
+          <a:lstStyle/>
+          <a:p>
+            <a:r>
+              <a:rPr lang="en-GB" dirty="0"/>
+              <a:t>Impose connectivity constraints</a:t>
+            </a:r>
+          </a:p>
+          <a:p>
+            <a:endParaRPr lang="en-GB" dirty="0"/>
+          </a:p>
+          <a:p>
+            <a:r>
+              <a:rPr lang="en-GB" dirty="0"/>
+              <a:t>Look at the </a:t>
+            </a:r>
+            <a:r>
+              <a:rPr lang="en-GB" dirty="0" err="1"/>
+              <a:t>tradeoff</a:t>
+            </a:r>
+            <a:r>
+              <a:rPr lang="en-GB" dirty="0"/>
+              <a:t> on converting</a:t>
+            </a:r>
+          </a:p>
+          <a:p>
+            <a:pPr marL="0" indent="0">
+              <a:buNone/>
+            </a:pPr>
+            <a:r>
+              <a:rPr lang="en-GB" dirty="0"/>
+              <a:t>	[[8, 6, 2]] 	-&gt;	2 x [[6, 4, 2]]	-&gt;	3 x [[4, 2, 2]]</a:t>
+            </a:r>
+          </a:p>
+        </p:txBody>
+      </p:sp>
+    </p:spTree>
+    <p:extLst>
+      <p:ext uri="{BB962C8B-B14F-4D97-AF65-F5344CB8AC3E}">
+        <p14:creationId xmlns:p14="http://schemas.microsoft.com/office/powerpoint/2010/main" val="335407208"/>
       </p:ext>
     </p:extLst>
   </p:cSld>
@@ -5019,8 +6608,8 @@
           </a:p>
         </p:txBody>
       </p:sp>
-      <mc:AlternateContent xmlns:mc="http://schemas.openxmlformats.org/markup-compatibility/2006">
-        <mc:Choice xmlns:a14="http://schemas.microsoft.com/office/drawing/2010/main" Requires="a14">
+      <mc:AlternateContent xmlns:mc="http://schemas.openxmlformats.org/markup-compatibility/2006" xmlns:a14="http://schemas.microsoft.com/office/drawing/2010/main">
+        <mc:Choice Requires="a14">
           <p:sp>
             <p:nvSpPr>
               <p:cNvPr id="3" name="Content Placeholder 2">
@@ -5138,7 +6727,7 @@
                         <m:d>
                           <m:dPr>
                             <m:ctrlPr>
-                              <a:rPr lang="en-US" b="0" i="0" smtClean="0">
+                              <a:rPr lang="en-US" b="0" i="1" smtClean="0">
                                 <a:latin typeface="Cambria Math" panose="02040503050406030204" pitchFamily="18" charset="0"/>
                                 <a:ea typeface="Cambria Math" panose="02040503050406030204" pitchFamily="18" charset="0"/>
                               </a:rPr>
@@ -5148,7 +6737,7 @@
                             <m:f>
                               <m:fPr>
                                 <m:ctrlPr>
-                                  <a:rPr lang="en-US" b="0" i="0" smtClean="0">
+                                  <a:rPr lang="en-US" b="0" i="1" smtClean="0">
                                     <a:latin typeface="Cambria Math" panose="02040503050406030204" pitchFamily="18" charset="0"/>
                                     <a:ea typeface="Cambria Math" panose="02040503050406030204" pitchFamily="18" charset="0"/>
                                   </a:rPr>
@@ -5203,7 +6792,7 @@
             </p:txBody>
           </p:sp>
         </mc:Choice>
-        <mc:Fallback>
+        <mc:Fallback xmlns="">
           <p:sp>
             <p:nvSpPr>
               <p:cNvPr id="3" name="Content Placeholder 2">

</xml_diff>

<commit_message>
Added IcebergGrid class and improved inheritance structure
</commit_message>
<xml_diff>
--- a/direction.pptx
+++ b/direction.pptx
@@ -32,6 +32,8 @@
     <p:sldId id="281" r:id="rId26"/>
     <p:sldId id="282" r:id="rId27"/>
     <p:sldId id="283" r:id="rId28"/>
+    <p:sldId id="284" r:id="rId29"/>
+    <p:sldId id="285" r:id="rId30"/>
   </p:sldIdLst>
   <p:sldSz cx="12192000" cy="6858000"/>
   <p:notesSz cx="6858000" cy="9144000"/>
@@ -287,7 +289,7 @@
           <a:p>
             <a:fld id="{B74604FD-B602-FC49-9746-E8C71C959787}" type="datetimeFigureOut">
               <a:rPr lang="en-US" smtClean="0"/>
-              <a:t>4/23/25</a:t>
+              <a:t>5/9/25</a:t>
             </a:fld>
             <a:endParaRPr lang="en-US"/>
           </a:p>
@@ -487,7 +489,7 @@
           <a:p>
             <a:fld id="{B74604FD-B602-FC49-9746-E8C71C959787}" type="datetimeFigureOut">
               <a:rPr lang="en-US" smtClean="0"/>
-              <a:t>4/23/25</a:t>
+              <a:t>5/9/25</a:t>
             </a:fld>
             <a:endParaRPr lang="en-US"/>
           </a:p>
@@ -697,7 +699,7 @@
           <a:p>
             <a:fld id="{B74604FD-B602-FC49-9746-E8C71C959787}" type="datetimeFigureOut">
               <a:rPr lang="en-US" smtClean="0"/>
-              <a:t>4/23/25</a:t>
+              <a:t>5/9/25</a:t>
             </a:fld>
             <a:endParaRPr lang="en-US"/>
           </a:p>
@@ -897,7 +899,7 @@
           <a:p>
             <a:fld id="{B74604FD-B602-FC49-9746-E8C71C959787}" type="datetimeFigureOut">
               <a:rPr lang="en-US" smtClean="0"/>
-              <a:t>4/23/25</a:t>
+              <a:t>5/9/25</a:t>
             </a:fld>
             <a:endParaRPr lang="en-US"/>
           </a:p>
@@ -1173,7 +1175,7 @@
           <a:p>
             <a:fld id="{B74604FD-B602-FC49-9746-E8C71C959787}" type="datetimeFigureOut">
               <a:rPr lang="en-US" smtClean="0"/>
-              <a:t>4/23/25</a:t>
+              <a:t>5/9/25</a:t>
             </a:fld>
             <a:endParaRPr lang="en-US"/>
           </a:p>
@@ -1441,7 +1443,7 @@
           <a:p>
             <a:fld id="{B74604FD-B602-FC49-9746-E8C71C959787}" type="datetimeFigureOut">
               <a:rPr lang="en-US" smtClean="0"/>
-              <a:t>4/23/25</a:t>
+              <a:t>5/9/25</a:t>
             </a:fld>
             <a:endParaRPr lang="en-US"/>
           </a:p>
@@ -1856,7 +1858,7 @@
           <a:p>
             <a:fld id="{B74604FD-B602-FC49-9746-E8C71C959787}" type="datetimeFigureOut">
               <a:rPr lang="en-US" smtClean="0"/>
-              <a:t>4/23/25</a:t>
+              <a:t>5/9/25</a:t>
             </a:fld>
             <a:endParaRPr lang="en-US"/>
           </a:p>
@@ -1998,7 +2000,7 @@
           <a:p>
             <a:fld id="{B74604FD-B602-FC49-9746-E8C71C959787}" type="datetimeFigureOut">
               <a:rPr lang="en-US" smtClean="0"/>
-              <a:t>4/23/25</a:t>
+              <a:t>5/9/25</a:t>
             </a:fld>
             <a:endParaRPr lang="en-US"/>
           </a:p>
@@ -2111,7 +2113,7 @@
           <a:p>
             <a:fld id="{B74604FD-B602-FC49-9746-E8C71C959787}" type="datetimeFigureOut">
               <a:rPr lang="en-US" smtClean="0"/>
-              <a:t>4/23/25</a:t>
+              <a:t>5/9/25</a:t>
             </a:fld>
             <a:endParaRPr lang="en-US"/>
           </a:p>
@@ -2424,7 +2426,7 @@
           <a:p>
             <a:fld id="{B74604FD-B602-FC49-9746-E8C71C959787}" type="datetimeFigureOut">
               <a:rPr lang="en-US" smtClean="0"/>
-              <a:t>4/23/25</a:t>
+              <a:t>5/9/25</a:t>
             </a:fld>
             <a:endParaRPr lang="en-US"/>
           </a:p>
@@ -2713,7 +2715,7 @@
           <a:p>
             <a:fld id="{B74604FD-B602-FC49-9746-E8C71C959787}" type="datetimeFigureOut">
               <a:rPr lang="en-US" smtClean="0"/>
-              <a:t>4/23/25</a:t>
+              <a:t>5/9/25</a:t>
             </a:fld>
             <a:endParaRPr lang="en-US"/>
           </a:p>
@@ -2956,7 +2958,7 @@
           <a:p>
             <a:fld id="{B74604FD-B602-FC49-9746-E8C71C959787}" type="datetimeFigureOut">
               <a:rPr lang="en-US" smtClean="0"/>
-              <a:t>4/23/25</a:t>
+              <a:t>5/9/25</a:t>
             </a:fld>
             <a:endParaRPr lang="en-US"/>
           </a:p>
@@ -6356,6 +6358,229 @@
     <p:extLst>
       <p:ext uri="{BB962C8B-B14F-4D97-AF65-F5344CB8AC3E}">
         <p14:creationId xmlns:p14="http://schemas.microsoft.com/office/powerpoint/2010/main" val="713959062"/>
+      </p:ext>
+    </p:extLst>
+  </p:cSld>
+  <p:clrMapOvr>
+    <a:masterClrMapping/>
+  </p:clrMapOvr>
+</p:sld>
+</file>
+
+<file path=ppt/slides/slide28.xml><?xml version="1.0" encoding="utf-8"?>
+<p:sld xmlns:a="http://schemas.openxmlformats.org/drawingml/2006/main" xmlns:r="http://schemas.openxmlformats.org/officeDocument/2006/relationships" xmlns:p="http://schemas.openxmlformats.org/presentationml/2006/main">
+  <p:cSld>
+    <p:spTree>
+      <p:nvGrpSpPr>
+        <p:cNvPr id="1" name=""/>
+        <p:cNvGrpSpPr/>
+        <p:nvPr/>
+      </p:nvGrpSpPr>
+      <p:grpSpPr>
+        <a:xfrm>
+          <a:off x="0" y="0"/>
+          <a:ext cx="0" cy="0"/>
+          <a:chOff x="0" y="0"/>
+          <a:chExt cx="0" cy="0"/>
+        </a:xfrm>
+      </p:grpSpPr>
+      <p:sp>
+        <p:nvSpPr>
+          <p:cNvPr id="2" name="Title 1">
+            <a:extLst>
+              <a:ext uri="{FF2B5EF4-FFF2-40B4-BE49-F238E27FC236}">
+                <a16:creationId xmlns:a16="http://schemas.microsoft.com/office/drawing/2014/main" id="{213F089C-F793-C796-74CB-155494903955}"/>
+              </a:ext>
+            </a:extLst>
+          </p:cNvPr>
+          <p:cNvSpPr>
+            <a:spLocks noGrp="1"/>
+          </p:cNvSpPr>
+          <p:nvPr>
+            <p:ph type="title"/>
+          </p:nvPr>
+        </p:nvSpPr>
+        <p:spPr>
+          <a:xfrm>
+            <a:off x="5070764" y="365125"/>
+            <a:ext cx="6283036" cy="1325563"/>
+          </a:xfrm>
+        </p:spPr>
+        <p:txBody>
+          <a:bodyPr/>
+          <a:lstStyle/>
+          <a:p>
+            <a:r>
+              <a:rPr lang="en-GB" dirty="0"/>
+              <a:t>Implementing Hadamard Test using [[4, 2, 2]]</a:t>
+            </a:r>
+          </a:p>
+        </p:txBody>
+      </p:sp>
+      <p:pic>
+        <p:nvPicPr>
+          <p:cNvPr id="7" name="Picture 6">
+            <a:extLst>
+              <a:ext uri="{FF2B5EF4-FFF2-40B4-BE49-F238E27FC236}">
+                <a16:creationId xmlns:a16="http://schemas.microsoft.com/office/drawing/2014/main" id="{E6FF43C4-6ACF-5411-010E-73AF65CB291E}"/>
+              </a:ext>
+            </a:extLst>
+          </p:cNvPr>
+          <p:cNvPicPr>
+            <a:picLocks noChangeAspect="1"/>
+          </p:cNvPicPr>
+          <p:nvPr/>
+        </p:nvPicPr>
+        <p:blipFill>
+          <a:blip r:embed="rId2"/>
+          <a:stretch>
+            <a:fillRect/>
+          </a:stretch>
+        </p:blipFill>
+        <p:spPr>
+          <a:xfrm>
+            <a:off x="4010891" y="1594228"/>
+            <a:ext cx="8067304" cy="5263772"/>
+          </a:xfrm>
+          <a:prstGeom prst="rect">
+            <a:avLst/>
+          </a:prstGeom>
+        </p:spPr>
+      </p:pic>
+      <p:pic>
+        <p:nvPicPr>
+          <p:cNvPr id="8" name="Picture 7">
+            <a:extLst>
+              <a:ext uri="{FF2B5EF4-FFF2-40B4-BE49-F238E27FC236}">
+                <a16:creationId xmlns:a16="http://schemas.microsoft.com/office/drawing/2014/main" id="{EAA2CE06-3886-226E-25DB-6B9A6A7D0647}"/>
+              </a:ext>
+            </a:extLst>
+          </p:cNvPr>
+          <p:cNvPicPr>
+            <a:picLocks noChangeAspect="1"/>
+          </p:cNvPicPr>
+          <p:nvPr/>
+        </p:nvPicPr>
+        <p:blipFill>
+          <a:blip r:embed="rId3"/>
+          <a:stretch>
+            <a:fillRect/>
+          </a:stretch>
+        </p:blipFill>
+        <p:spPr>
+          <a:xfrm>
+            <a:off x="321623" y="98426"/>
+            <a:ext cx="4608068" cy="1762502"/>
+          </a:xfrm>
+          <a:prstGeom prst="rect">
+            <a:avLst/>
+          </a:prstGeom>
+        </p:spPr>
+      </p:pic>
+    </p:spTree>
+    <p:extLst>
+      <p:ext uri="{BB962C8B-B14F-4D97-AF65-F5344CB8AC3E}">
+        <p14:creationId xmlns:p14="http://schemas.microsoft.com/office/powerpoint/2010/main" val="2140056534"/>
+      </p:ext>
+    </p:extLst>
+  </p:cSld>
+  <p:clrMapOvr>
+    <a:masterClrMapping/>
+  </p:clrMapOvr>
+</p:sld>
+</file>
+
+<file path=ppt/slides/slide29.xml><?xml version="1.0" encoding="utf-8"?>
+<p:sld xmlns:a="http://schemas.openxmlformats.org/drawingml/2006/main" xmlns:r="http://schemas.openxmlformats.org/officeDocument/2006/relationships" xmlns:p="http://schemas.openxmlformats.org/presentationml/2006/main">
+  <p:cSld>
+    <p:spTree>
+      <p:nvGrpSpPr>
+        <p:cNvPr id="1" name=""/>
+        <p:cNvGrpSpPr/>
+        <p:nvPr/>
+      </p:nvGrpSpPr>
+      <p:grpSpPr>
+        <a:xfrm>
+          <a:off x="0" y="0"/>
+          <a:ext cx="0" cy="0"/>
+          <a:chOff x="0" y="0"/>
+          <a:chExt cx="0" cy="0"/>
+        </a:xfrm>
+      </p:grpSpPr>
+      <p:sp>
+        <p:nvSpPr>
+          <p:cNvPr id="2" name="Title 1">
+            <a:extLst>
+              <a:ext uri="{FF2B5EF4-FFF2-40B4-BE49-F238E27FC236}">
+                <a16:creationId xmlns:a16="http://schemas.microsoft.com/office/drawing/2014/main" id="{4494FE98-D17E-AABB-9A0E-6D7CA690B216}"/>
+              </a:ext>
+            </a:extLst>
+          </p:cNvPr>
+          <p:cNvSpPr>
+            <a:spLocks noGrp="1"/>
+          </p:cNvSpPr>
+          <p:nvPr>
+            <p:ph type="title"/>
+          </p:nvPr>
+        </p:nvSpPr>
+        <p:spPr/>
+        <p:txBody>
+          <a:bodyPr/>
+          <a:lstStyle/>
+          <a:p>
+            <a:r>
+              <a:rPr lang="en-GB" dirty="0"/>
+              <a:t>Questions</a:t>
+            </a:r>
+          </a:p>
+        </p:txBody>
+      </p:sp>
+      <p:sp>
+        <p:nvSpPr>
+          <p:cNvPr id="3" name="Content Placeholder 2">
+            <a:extLst>
+              <a:ext uri="{FF2B5EF4-FFF2-40B4-BE49-F238E27FC236}">
+                <a16:creationId xmlns:a16="http://schemas.microsoft.com/office/drawing/2014/main" id="{351C3A8D-49BE-E11C-9D80-8B22EEAFC895}"/>
+              </a:ext>
+            </a:extLst>
+          </p:cNvPr>
+          <p:cNvSpPr>
+            <a:spLocks noGrp="1"/>
+          </p:cNvSpPr>
+          <p:nvPr>
+            <p:ph idx="1"/>
+          </p:nvPr>
+        </p:nvSpPr>
+        <p:spPr/>
+        <p:txBody>
+          <a:bodyPr/>
+          <a:lstStyle/>
+          <a:p>
+            <a:r>
+              <a:rPr lang="en-GB" dirty="0"/>
+              <a:t>What about the movement that is needed for the final decoding step?</a:t>
+            </a:r>
+          </a:p>
+          <a:p>
+            <a:endParaRPr lang="en-GB" dirty="0"/>
+          </a:p>
+          <a:p>
+            <a:r>
+              <a:rPr lang="en-GB" dirty="0"/>
+              <a:t>What is the difference between version 1 and 2 of the </a:t>
+            </a:r>
+            <a:r>
+              <a:rPr lang="en-GB"/>
+              <a:t>circuits?</a:t>
+            </a:r>
+            <a:endParaRPr lang="en-GB" dirty="0"/>
+          </a:p>
+        </p:txBody>
+      </p:sp>
+    </p:spTree>
+    <p:extLst>
+      <p:ext uri="{BB962C8B-B14F-4D97-AF65-F5344CB8AC3E}">
+        <p14:creationId xmlns:p14="http://schemas.microsoft.com/office/powerpoint/2010/main" val="2645722377"/>
       </p:ext>
     </p:extLst>
   </p:cSld>

</xml_diff>

<commit_message>
Added IcebergGrid class, improved class structure; additionally some simulations of Hadamard test circuit (#4)
* Added CZ, S, decode, measure to iceberg

formatted random_circuit_gen; fixed environ import in generalized_shor

* Moved random_circuit_gen to circuits; added code to compare resilience of iceberg vs physical compilation

* improved random_circuit_gen script

* Added IcebergGrid class and improved inheritance structure

* Ran initial Hadamard test experiments

* Cleaned up generalized_shor.py
</commit_message>
<xml_diff>
--- a/direction.pptx
+++ b/direction.pptx
@@ -27,6 +27,13 @@
     <p:sldId id="275" r:id="rId21"/>
     <p:sldId id="276" r:id="rId22"/>
     <p:sldId id="277" r:id="rId23"/>
+    <p:sldId id="278" r:id="rId24"/>
+    <p:sldId id="280" r:id="rId25"/>
+    <p:sldId id="281" r:id="rId26"/>
+    <p:sldId id="282" r:id="rId27"/>
+    <p:sldId id="283" r:id="rId28"/>
+    <p:sldId id="284" r:id="rId29"/>
+    <p:sldId id="285" r:id="rId30"/>
   </p:sldIdLst>
   <p:sldSz cx="12192000" cy="6858000"/>
   <p:notesSz cx="6858000" cy="9144000"/>
@@ -282,7 +289,7 @@
           <a:p>
             <a:fld id="{B74604FD-B602-FC49-9746-E8C71C959787}" type="datetimeFigureOut">
               <a:rPr lang="en-US" smtClean="0"/>
-              <a:t>4/18/25</a:t>
+              <a:t>5/9/25</a:t>
             </a:fld>
             <a:endParaRPr lang="en-US"/>
           </a:p>
@@ -482,7 +489,7 @@
           <a:p>
             <a:fld id="{B74604FD-B602-FC49-9746-E8C71C959787}" type="datetimeFigureOut">
               <a:rPr lang="en-US" smtClean="0"/>
-              <a:t>4/18/25</a:t>
+              <a:t>5/9/25</a:t>
             </a:fld>
             <a:endParaRPr lang="en-US"/>
           </a:p>
@@ -692,7 +699,7 @@
           <a:p>
             <a:fld id="{B74604FD-B602-FC49-9746-E8C71C959787}" type="datetimeFigureOut">
               <a:rPr lang="en-US" smtClean="0"/>
-              <a:t>4/18/25</a:t>
+              <a:t>5/9/25</a:t>
             </a:fld>
             <a:endParaRPr lang="en-US"/>
           </a:p>
@@ -892,7 +899,7 @@
           <a:p>
             <a:fld id="{B74604FD-B602-FC49-9746-E8C71C959787}" type="datetimeFigureOut">
               <a:rPr lang="en-US" smtClean="0"/>
-              <a:t>4/18/25</a:t>
+              <a:t>5/9/25</a:t>
             </a:fld>
             <a:endParaRPr lang="en-US"/>
           </a:p>
@@ -1168,7 +1175,7 @@
           <a:p>
             <a:fld id="{B74604FD-B602-FC49-9746-E8C71C959787}" type="datetimeFigureOut">
               <a:rPr lang="en-US" smtClean="0"/>
-              <a:t>4/18/25</a:t>
+              <a:t>5/9/25</a:t>
             </a:fld>
             <a:endParaRPr lang="en-US"/>
           </a:p>
@@ -1436,7 +1443,7 @@
           <a:p>
             <a:fld id="{B74604FD-B602-FC49-9746-E8C71C959787}" type="datetimeFigureOut">
               <a:rPr lang="en-US" smtClean="0"/>
-              <a:t>4/18/25</a:t>
+              <a:t>5/9/25</a:t>
             </a:fld>
             <a:endParaRPr lang="en-US"/>
           </a:p>
@@ -1851,7 +1858,7 @@
           <a:p>
             <a:fld id="{B74604FD-B602-FC49-9746-E8C71C959787}" type="datetimeFigureOut">
               <a:rPr lang="en-US" smtClean="0"/>
-              <a:t>4/18/25</a:t>
+              <a:t>5/9/25</a:t>
             </a:fld>
             <a:endParaRPr lang="en-US"/>
           </a:p>
@@ -1993,7 +2000,7 @@
           <a:p>
             <a:fld id="{B74604FD-B602-FC49-9746-E8C71C959787}" type="datetimeFigureOut">
               <a:rPr lang="en-US" smtClean="0"/>
-              <a:t>4/18/25</a:t>
+              <a:t>5/9/25</a:t>
             </a:fld>
             <a:endParaRPr lang="en-US"/>
           </a:p>
@@ -2106,7 +2113,7 @@
           <a:p>
             <a:fld id="{B74604FD-B602-FC49-9746-E8C71C959787}" type="datetimeFigureOut">
               <a:rPr lang="en-US" smtClean="0"/>
-              <a:t>4/18/25</a:t>
+              <a:t>5/9/25</a:t>
             </a:fld>
             <a:endParaRPr lang="en-US"/>
           </a:p>
@@ -2419,7 +2426,7 @@
           <a:p>
             <a:fld id="{B74604FD-B602-FC49-9746-E8C71C959787}" type="datetimeFigureOut">
               <a:rPr lang="en-US" smtClean="0"/>
-              <a:t>4/18/25</a:t>
+              <a:t>5/9/25</a:t>
             </a:fld>
             <a:endParaRPr lang="en-US"/>
           </a:p>
@@ -2708,7 +2715,7 @@
           <a:p>
             <a:fld id="{B74604FD-B602-FC49-9746-E8C71C959787}" type="datetimeFigureOut">
               <a:rPr lang="en-US" smtClean="0"/>
-              <a:t>4/18/25</a:t>
+              <a:t>5/9/25</a:t>
             </a:fld>
             <a:endParaRPr lang="en-US"/>
           </a:p>
@@ -2951,7 +2958,7 @@
           <a:p>
             <a:fld id="{B74604FD-B602-FC49-9746-E8C71C959787}" type="datetimeFigureOut">
               <a:rPr lang="en-US" smtClean="0"/>
-              <a:t>4/18/25</a:t>
+              <a:t>5/9/25</a:t>
             </a:fld>
             <a:endParaRPr lang="en-US"/>
           </a:p>
@@ -5700,6 +5707,880 @@
     <p:extLst>
       <p:ext uri="{BB962C8B-B14F-4D97-AF65-F5344CB8AC3E}">
         <p14:creationId xmlns:p14="http://schemas.microsoft.com/office/powerpoint/2010/main" val="335407208"/>
+      </p:ext>
+    </p:extLst>
+  </p:cSld>
+  <p:clrMapOvr>
+    <a:masterClrMapping/>
+  </p:clrMapOvr>
+</p:sld>
+</file>
+
+<file path=ppt/slides/slide23.xml><?xml version="1.0" encoding="utf-8"?>
+<p:sld xmlns:a="http://schemas.openxmlformats.org/drawingml/2006/main" xmlns:r="http://schemas.openxmlformats.org/officeDocument/2006/relationships" xmlns:p="http://schemas.openxmlformats.org/presentationml/2006/main">
+  <p:cSld>
+    <p:spTree>
+      <p:nvGrpSpPr>
+        <p:cNvPr id="1" name=""/>
+        <p:cNvGrpSpPr/>
+        <p:nvPr/>
+      </p:nvGrpSpPr>
+      <p:grpSpPr>
+        <a:xfrm>
+          <a:off x="0" y="0"/>
+          <a:ext cx="0" cy="0"/>
+          <a:chOff x="0" y="0"/>
+          <a:chExt cx="0" cy="0"/>
+        </a:xfrm>
+      </p:grpSpPr>
+      <p:sp>
+        <p:nvSpPr>
+          <p:cNvPr id="2" name="Title 1">
+            <a:extLst>
+              <a:ext uri="{FF2B5EF4-FFF2-40B4-BE49-F238E27FC236}">
+                <a16:creationId xmlns:a16="http://schemas.microsoft.com/office/drawing/2014/main" id="{5D31D2F2-CE48-3694-0329-F2AE31756DD9}"/>
+              </a:ext>
+            </a:extLst>
+          </p:cNvPr>
+          <p:cNvSpPr>
+            <a:spLocks noGrp="1"/>
+          </p:cNvSpPr>
+          <p:nvPr>
+            <p:ph type="title"/>
+          </p:nvPr>
+        </p:nvSpPr>
+        <p:spPr/>
+        <p:txBody>
+          <a:bodyPr/>
+          <a:lstStyle/>
+          <a:p>
+            <a:r>
+              <a:rPr lang="en-GB" dirty="0"/>
+              <a:t>Physical Error Rate Requirements for Iceberg</a:t>
+            </a:r>
+          </a:p>
+        </p:txBody>
+      </p:sp>
+      <p:sp>
+        <p:nvSpPr>
+          <p:cNvPr id="3" name="Content Placeholder 2">
+            <a:extLst>
+              <a:ext uri="{FF2B5EF4-FFF2-40B4-BE49-F238E27FC236}">
+                <a16:creationId xmlns:a16="http://schemas.microsoft.com/office/drawing/2014/main" id="{1BBF5FD1-E280-E970-04A2-6C9F9A6437D1}"/>
+              </a:ext>
+            </a:extLst>
+          </p:cNvPr>
+          <p:cNvSpPr>
+            <a:spLocks noGrp="1"/>
+          </p:cNvSpPr>
+          <p:nvPr>
+            <p:ph idx="1"/>
+          </p:nvPr>
+        </p:nvSpPr>
+        <p:spPr/>
+        <p:txBody>
+          <a:bodyPr/>
+          <a:lstStyle/>
+          <a:p>
+            <a:r>
+              <a:rPr lang="en-GB" dirty="0"/>
+              <a:t>Executed circuit C followed by C^\</a:t>
+            </a:r>
+            <a:r>
+              <a:rPr lang="en-GB" dirty="0" err="1"/>
+              <a:t>dag</a:t>
+            </a:r>
+            <a:r>
+              <a:rPr lang="en-GB" dirty="0"/>
+              <a:t> (with optimizations off)</a:t>
+            </a:r>
+          </a:p>
+          <a:p>
+            <a:r>
+              <a:rPr lang="en-GB" dirty="0"/>
+              <a:t>The output should be the all-0 state</a:t>
+            </a:r>
+          </a:p>
+        </p:txBody>
+      </p:sp>
+      <p:pic>
+        <p:nvPicPr>
+          <p:cNvPr id="5" name="Picture 4" descr="A diagram of a diagram&#10;&#10;AI-generated content may be incorrect.">
+            <a:extLst>
+              <a:ext uri="{FF2B5EF4-FFF2-40B4-BE49-F238E27FC236}">
+                <a16:creationId xmlns:a16="http://schemas.microsoft.com/office/drawing/2014/main" id="{21FE1993-2B23-01D1-B610-DB90D8908080}"/>
+              </a:ext>
+            </a:extLst>
+          </p:cNvPr>
+          <p:cNvPicPr>
+            <a:picLocks noChangeAspect="1"/>
+          </p:cNvPicPr>
+          <p:nvPr/>
+        </p:nvPicPr>
+        <p:blipFill>
+          <a:blip r:embed="rId2"/>
+          <a:stretch>
+            <a:fillRect/>
+          </a:stretch>
+        </p:blipFill>
+        <p:spPr>
+          <a:xfrm>
+            <a:off x="2209800" y="2956089"/>
+            <a:ext cx="7772400" cy="3788433"/>
+          </a:xfrm>
+          <a:prstGeom prst="rect">
+            <a:avLst/>
+          </a:prstGeom>
+        </p:spPr>
+      </p:pic>
+    </p:spTree>
+    <p:extLst>
+      <p:ext uri="{BB962C8B-B14F-4D97-AF65-F5344CB8AC3E}">
+        <p14:creationId xmlns:p14="http://schemas.microsoft.com/office/powerpoint/2010/main" val="1577688267"/>
+      </p:ext>
+    </p:extLst>
+  </p:cSld>
+  <p:clrMapOvr>
+    <a:masterClrMapping/>
+  </p:clrMapOvr>
+</p:sld>
+</file>
+
+<file path=ppt/slides/slide24.xml><?xml version="1.0" encoding="utf-8"?>
+<p:sld xmlns:a="http://schemas.openxmlformats.org/drawingml/2006/main" xmlns:r="http://schemas.openxmlformats.org/officeDocument/2006/relationships" xmlns:p="http://schemas.openxmlformats.org/presentationml/2006/main">
+  <p:cSld>
+    <p:spTree>
+      <p:nvGrpSpPr>
+        <p:cNvPr id="1" name="">
+          <a:extLst>
+            <a:ext uri="{FF2B5EF4-FFF2-40B4-BE49-F238E27FC236}">
+              <a16:creationId xmlns:a16="http://schemas.microsoft.com/office/drawing/2014/main" id="{0F63304D-4204-E20F-BD03-5F51CAF533F6}"/>
+            </a:ext>
+          </a:extLst>
+        </p:cNvPr>
+        <p:cNvGrpSpPr/>
+        <p:nvPr/>
+      </p:nvGrpSpPr>
+      <p:grpSpPr>
+        <a:xfrm>
+          <a:off x="0" y="0"/>
+          <a:ext cx="0" cy="0"/>
+          <a:chOff x="0" y="0"/>
+          <a:chExt cx="0" cy="0"/>
+        </a:xfrm>
+      </p:grpSpPr>
+      <p:sp>
+        <p:nvSpPr>
+          <p:cNvPr id="2" name="Title 1">
+            <a:extLst>
+              <a:ext uri="{FF2B5EF4-FFF2-40B4-BE49-F238E27FC236}">
+                <a16:creationId xmlns:a16="http://schemas.microsoft.com/office/drawing/2014/main" id="{81D32252-F476-9106-C9DE-AAAA7E135957}"/>
+              </a:ext>
+            </a:extLst>
+          </p:cNvPr>
+          <p:cNvSpPr>
+            <a:spLocks noGrp="1"/>
+          </p:cNvSpPr>
+          <p:nvPr>
+            <p:ph type="title"/>
+          </p:nvPr>
+        </p:nvSpPr>
+        <p:spPr/>
+        <p:txBody>
+          <a:bodyPr/>
+          <a:lstStyle/>
+          <a:p>
+            <a:r>
+              <a:rPr lang="en-GB" dirty="0"/>
+              <a:t>Physical Error Rate Requirements for Iceberg</a:t>
+            </a:r>
+          </a:p>
+        </p:txBody>
+      </p:sp>
+      <p:sp>
+        <p:nvSpPr>
+          <p:cNvPr id="3" name="Content Placeholder 2">
+            <a:extLst>
+              <a:ext uri="{FF2B5EF4-FFF2-40B4-BE49-F238E27FC236}">
+                <a16:creationId xmlns:a16="http://schemas.microsoft.com/office/drawing/2014/main" id="{8168F788-755E-92F6-D1E5-DAF09B438CEA}"/>
+              </a:ext>
+            </a:extLst>
+          </p:cNvPr>
+          <p:cNvSpPr>
+            <a:spLocks noGrp="1"/>
+          </p:cNvSpPr>
+          <p:nvPr>
+            <p:ph idx="1"/>
+          </p:nvPr>
+        </p:nvSpPr>
+        <p:spPr/>
+        <p:txBody>
+          <a:bodyPr/>
+          <a:lstStyle/>
+          <a:p>
+            <a:r>
+              <a:rPr lang="en-GB" dirty="0"/>
+              <a:t>Used a Pauli noise model with equal probabilities of X, Z and Y.</a:t>
+            </a:r>
+          </a:p>
+          <a:p>
+            <a:r>
+              <a:rPr lang="en-GB" dirty="0"/>
+              <a:t>Qubit initialization error probability (reset) = 3%</a:t>
+            </a:r>
+          </a:p>
+          <a:p>
+            <a:r>
+              <a:rPr lang="en-GB" dirty="0"/>
+              <a:t>Qubit readout error probability (measure) = 3%</a:t>
+            </a:r>
+          </a:p>
+          <a:p>
+            <a:r>
+              <a:rPr lang="en-GB" dirty="0"/>
+              <a:t>1-qubit gate error probability = 0.1%</a:t>
+            </a:r>
+          </a:p>
+          <a:p>
+            <a:r>
+              <a:rPr lang="en-GB" dirty="0"/>
+              <a:t>2-qubit gate error probability = 1%</a:t>
+            </a:r>
+          </a:p>
+          <a:p>
+            <a:r>
+              <a:rPr lang="en-GB" dirty="0"/>
+              <a:t>All error rates are multiplied with “alpha” to see how iceberg compares against physical compilation</a:t>
+            </a:r>
+          </a:p>
+        </p:txBody>
+      </p:sp>
+    </p:spTree>
+    <p:extLst>
+      <p:ext uri="{BB962C8B-B14F-4D97-AF65-F5344CB8AC3E}">
+        <p14:creationId xmlns:p14="http://schemas.microsoft.com/office/powerpoint/2010/main" val="749766148"/>
+      </p:ext>
+    </p:extLst>
+  </p:cSld>
+  <p:clrMapOvr>
+    <a:masterClrMapping/>
+  </p:clrMapOvr>
+</p:sld>
+</file>
+
+<file path=ppt/slides/slide25.xml><?xml version="1.0" encoding="utf-8"?>
+<p:sld xmlns:a="http://schemas.openxmlformats.org/drawingml/2006/main" xmlns:r="http://schemas.openxmlformats.org/officeDocument/2006/relationships" xmlns:p="http://schemas.openxmlformats.org/presentationml/2006/main">
+  <p:cSld>
+    <p:spTree>
+      <p:nvGrpSpPr>
+        <p:cNvPr id="1" name="">
+          <a:extLst>
+            <a:ext uri="{FF2B5EF4-FFF2-40B4-BE49-F238E27FC236}">
+              <a16:creationId xmlns:a16="http://schemas.microsoft.com/office/drawing/2014/main" id="{1D384A13-C540-F3AC-B569-F5F67E7EF4AB}"/>
+            </a:ext>
+          </a:extLst>
+        </p:cNvPr>
+        <p:cNvGrpSpPr/>
+        <p:nvPr/>
+      </p:nvGrpSpPr>
+      <p:grpSpPr>
+        <a:xfrm>
+          <a:off x="0" y="0"/>
+          <a:ext cx="0" cy="0"/>
+          <a:chOff x="0" y="0"/>
+          <a:chExt cx="0" cy="0"/>
+        </a:xfrm>
+      </p:grpSpPr>
+      <p:sp>
+        <p:nvSpPr>
+          <p:cNvPr id="2" name="Title 1">
+            <a:extLst>
+              <a:ext uri="{FF2B5EF4-FFF2-40B4-BE49-F238E27FC236}">
+                <a16:creationId xmlns:a16="http://schemas.microsoft.com/office/drawing/2014/main" id="{1C7026C9-DC72-9F77-4D5E-D11B2009D5C3}"/>
+              </a:ext>
+            </a:extLst>
+          </p:cNvPr>
+          <p:cNvSpPr>
+            <a:spLocks noGrp="1"/>
+          </p:cNvSpPr>
+          <p:nvPr>
+            <p:ph type="title"/>
+          </p:nvPr>
+        </p:nvSpPr>
+        <p:spPr/>
+        <p:txBody>
+          <a:bodyPr/>
+          <a:lstStyle/>
+          <a:p>
+            <a:r>
+              <a:rPr lang="en-GB" dirty="0"/>
+              <a:t>Physical Error Rate Requirements for Iceberg</a:t>
+            </a:r>
+          </a:p>
+        </p:txBody>
+      </p:sp>
+      <p:pic>
+        <p:nvPicPr>
+          <p:cNvPr id="7" name="Content Placeholder 6" descr="A graph of different shapes and colors&#10;&#10;AI-generated content may be incorrect.">
+            <a:extLst>
+              <a:ext uri="{FF2B5EF4-FFF2-40B4-BE49-F238E27FC236}">
+                <a16:creationId xmlns:a16="http://schemas.microsoft.com/office/drawing/2014/main" id="{ACEADB26-D941-22C3-5CEB-59D43F465595}"/>
+              </a:ext>
+            </a:extLst>
+          </p:cNvPr>
+          <p:cNvPicPr>
+            <a:picLocks noGrp="1" noChangeAspect="1"/>
+          </p:cNvPicPr>
+          <p:nvPr>
+            <p:ph idx="1"/>
+          </p:nvPr>
+        </p:nvPicPr>
+        <p:blipFill>
+          <a:blip r:embed="rId2"/>
+          <a:stretch>
+            <a:fillRect/>
+          </a:stretch>
+        </p:blipFill>
+        <p:spPr>
+          <a:xfrm>
+            <a:off x="0" y="1340054"/>
+            <a:ext cx="6277047" cy="2874854"/>
+          </a:xfrm>
+        </p:spPr>
+      </p:pic>
+      <p:pic>
+        <p:nvPicPr>
+          <p:cNvPr id="9" name="Picture 8" descr="A graph of a graph showing the number of objects&#10;&#10;AI-generated content may be incorrect.">
+            <a:extLst>
+              <a:ext uri="{FF2B5EF4-FFF2-40B4-BE49-F238E27FC236}">
+                <a16:creationId xmlns:a16="http://schemas.microsoft.com/office/drawing/2014/main" id="{853092E1-3E3E-2743-AE1C-ED6A15F5771C}"/>
+              </a:ext>
+            </a:extLst>
+          </p:cNvPr>
+          <p:cNvPicPr>
+            <a:picLocks noChangeAspect="1"/>
+          </p:cNvPicPr>
+          <p:nvPr/>
+        </p:nvPicPr>
+        <p:blipFill>
+          <a:blip r:embed="rId3"/>
+          <a:stretch>
+            <a:fillRect/>
+          </a:stretch>
+        </p:blipFill>
+        <p:spPr>
+          <a:xfrm>
+            <a:off x="5558082" y="3594457"/>
+            <a:ext cx="6277047" cy="2898418"/>
+          </a:xfrm>
+          <a:prstGeom prst="rect">
+            <a:avLst/>
+          </a:prstGeom>
+        </p:spPr>
+      </p:pic>
+    </p:spTree>
+    <p:extLst>
+      <p:ext uri="{BB962C8B-B14F-4D97-AF65-F5344CB8AC3E}">
+        <p14:creationId xmlns:p14="http://schemas.microsoft.com/office/powerpoint/2010/main" val="4009015493"/>
+      </p:ext>
+    </p:extLst>
+  </p:cSld>
+  <p:clrMapOvr>
+    <a:masterClrMapping/>
+  </p:clrMapOvr>
+</p:sld>
+</file>
+
+<file path=ppt/slides/slide26.xml><?xml version="1.0" encoding="utf-8"?>
+<p:sld xmlns:a="http://schemas.openxmlformats.org/drawingml/2006/main" xmlns:r="http://schemas.openxmlformats.org/officeDocument/2006/relationships" xmlns:p="http://schemas.openxmlformats.org/presentationml/2006/main">
+  <p:cSld>
+    <p:spTree>
+      <p:nvGrpSpPr>
+        <p:cNvPr id="1" name="">
+          <a:extLst>
+            <a:ext uri="{FF2B5EF4-FFF2-40B4-BE49-F238E27FC236}">
+              <a16:creationId xmlns:a16="http://schemas.microsoft.com/office/drawing/2014/main" id="{4FE38906-250D-3F5E-E18A-B9739CA22D4D}"/>
+            </a:ext>
+          </a:extLst>
+        </p:cNvPr>
+        <p:cNvGrpSpPr/>
+        <p:nvPr/>
+      </p:nvGrpSpPr>
+      <p:grpSpPr>
+        <a:xfrm>
+          <a:off x="0" y="0"/>
+          <a:ext cx="0" cy="0"/>
+          <a:chOff x="0" y="0"/>
+          <a:chExt cx="0" cy="0"/>
+        </a:xfrm>
+      </p:grpSpPr>
+      <p:sp>
+        <p:nvSpPr>
+          <p:cNvPr id="2" name="Title 1">
+            <a:extLst>
+              <a:ext uri="{FF2B5EF4-FFF2-40B4-BE49-F238E27FC236}">
+                <a16:creationId xmlns:a16="http://schemas.microsoft.com/office/drawing/2014/main" id="{99250504-3CA4-B625-ACA8-D94F8239BD6D}"/>
+              </a:ext>
+            </a:extLst>
+          </p:cNvPr>
+          <p:cNvSpPr>
+            <a:spLocks noGrp="1"/>
+          </p:cNvSpPr>
+          <p:nvPr>
+            <p:ph type="title"/>
+          </p:nvPr>
+        </p:nvSpPr>
+        <p:spPr/>
+        <p:txBody>
+          <a:bodyPr/>
+          <a:lstStyle/>
+          <a:p>
+            <a:r>
+              <a:rPr lang="en-GB" dirty="0"/>
+              <a:t>Physical Error Rate Requirements for Iceberg</a:t>
+            </a:r>
+          </a:p>
+        </p:txBody>
+      </p:sp>
+      <p:pic>
+        <p:nvPicPr>
+          <p:cNvPr id="6" name="Content Placeholder 5" descr="A graph of different shapes and sizes&#10;&#10;AI-generated content may be incorrect.">
+            <a:extLst>
+              <a:ext uri="{FF2B5EF4-FFF2-40B4-BE49-F238E27FC236}">
+                <a16:creationId xmlns:a16="http://schemas.microsoft.com/office/drawing/2014/main" id="{8E7A9EF2-227C-2230-8155-F745D8FF135B}"/>
+              </a:ext>
+            </a:extLst>
+          </p:cNvPr>
+          <p:cNvPicPr>
+            <a:picLocks noGrp="1" noChangeAspect="1"/>
+          </p:cNvPicPr>
+          <p:nvPr>
+            <p:ph idx="1"/>
+          </p:nvPr>
+        </p:nvPicPr>
+        <p:blipFill>
+          <a:blip r:embed="rId2"/>
+          <a:stretch>
+            <a:fillRect/>
+          </a:stretch>
+        </p:blipFill>
+        <p:spPr>
+          <a:xfrm>
+            <a:off x="96539" y="1375197"/>
+            <a:ext cx="5538897" cy="2536785"/>
+          </a:xfrm>
+        </p:spPr>
+      </p:pic>
+      <p:pic>
+        <p:nvPicPr>
+          <p:cNvPr id="10" name="Picture 9" descr="A graph of a graph&#10;&#10;AI-generated content may be incorrect.">
+            <a:extLst>
+              <a:ext uri="{FF2B5EF4-FFF2-40B4-BE49-F238E27FC236}">
+                <a16:creationId xmlns:a16="http://schemas.microsoft.com/office/drawing/2014/main" id="{1414D0AF-51DB-E277-D167-3A265C830156}"/>
+              </a:ext>
+            </a:extLst>
+          </p:cNvPr>
+          <p:cNvPicPr>
+            <a:picLocks noChangeAspect="1"/>
+          </p:cNvPicPr>
+          <p:nvPr/>
+        </p:nvPicPr>
+        <p:blipFill>
+          <a:blip r:embed="rId3"/>
+          <a:stretch>
+            <a:fillRect/>
+          </a:stretch>
+        </p:blipFill>
+        <p:spPr>
+          <a:xfrm>
+            <a:off x="5721079" y="1375197"/>
+            <a:ext cx="5632721" cy="2626013"/>
+          </a:xfrm>
+          <a:prstGeom prst="rect">
+            <a:avLst/>
+          </a:prstGeom>
+        </p:spPr>
+      </p:pic>
+      <p:pic>
+        <p:nvPicPr>
+          <p:cNvPr id="12" name="Picture 11" descr="A graph of a number of objects&#10;&#10;AI-generated content may be incorrect.">
+            <a:extLst>
+              <a:ext uri="{FF2B5EF4-FFF2-40B4-BE49-F238E27FC236}">
+                <a16:creationId xmlns:a16="http://schemas.microsoft.com/office/drawing/2014/main" id="{EB3862AF-537D-2C01-37AC-63E64992C47F}"/>
+              </a:ext>
+            </a:extLst>
+          </p:cNvPr>
+          <p:cNvPicPr>
+            <a:picLocks noChangeAspect="1"/>
+          </p:cNvPicPr>
+          <p:nvPr/>
+        </p:nvPicPr>
+        <p:blipFill>
+          <a:blip r:embed="rId4"/>
+          <a:stretch>
+            <a:fillRect/>
+          </a:stretch>
+        </p:blipFill>
+        <p:spPr>
+          <a:xfrm>
+            <a:off x="3279639" y="4001210"/>
+            <a:ext cx="5632721" cy="2626013"/>
+          </a:xfrm>
+          <a:prstGeom prst="rect">
+            <a:avLst/>
+          </a:prstGeom>
+        </p:spPr>
+      </p:pic>
+    </p:spTree>
+    <p:extLst>
+      <p:ext uri="{BB962C8B-B14F-4D97-AF65-F5344CB8AC3E}">
+        <p14:creationId xmlns:p14="http://schemas.microsoft.com/office/powerpoint/2010/main" val="621565499"/>
+      </p:ext>
+    </p:extLst>
+  </p:cSld>
+  <p:clrMapOvr>
+    <a:masterClrMapping/>
+  </p:clrMapOvr>
+</p:sld>
+</file>
+
+<file path=ppt/slides/slide27.xml><?xml version="1.0" encoding="utf-8"?>
+<p:sld xmlns:a="http://schemas.openxmlformats.org/drawingml/2006/main" xmlns:r="http://schemas.openxmlformats.org/officeDocument/2006/relationships" xmlns:p="http://schemas.openxmlformats.org/presentationml/2006/main">
+  <p:cSld>
+    <p:spTree>
+      <p:nvGrpSpPr>
+        <p:cNvPr id="1" name=""/>
+        <p:cNvGrpSpPr/>
+        <p:nvPr/>
+      </p:nvGrpSpPr>
+      <p:grpSpPr>
+        <a:xfrm>
+          <a:off x="0" y="0"/>
+          <a:ext cx="0" cy="0"/>
+          <a:chOff x="0" y="0"/>
+          <a:chExt cx="0" cy="0"/>
+        </a:xfrm>
+      </p:grpSpPr>
+      <p:sp>
+        <p:nvSpPr>
+          <p:cNvPr id="2" name="Title 1">
+            <a:extLst>
+              <a:ext uri="{FF2B5EF4-FFF2-40B4-BE49-F238E27FC236}">
+                <a16:creationId xmlns:a16="http://schemas.microsoft.com/office/drawing/2014/main" id="{1F537FAE-2FE1-5199-5827-323E2D5C359A}"/>
+              </a:ext>
+            </a:extLst>
+          </p:cNvPr>
+          <p:cNvSpPr>
+            <a:spLocks noGrp="1"/>
+          </p:cNvSpPr>
+          <p:nvPr>
+            <p:ph type="title"/>
+          </p:nvPr>
+        </p:nvSpPr>
+        <p:spPr/>
+        <p:txBody>
+          <a:bodyPr/>
+          <a:lstStyle/>
+          <a:p>
+            <a:r>
+              <a:rPr lang="en-GB" dirty="0"/>
+              <a:t>Physical Error Rate Requirements for Iceberg</a:t>
+            </a:r>
+          </a:p>
+        </p:txBody>
+      </p:sp>
+      <p:sp>
+        <p:nvSpPr>
+          <p:cNvPr id="3" name="Content Placeholder 2">
+            <a:extLst>
+              <a:ext uri="{FF2B5EF4-FFF2-40B4-BE49-F238E27FC236}">
+                <a16:creationId xmlns:a16="http://schemas.microsoft.com/office/drawing/2014/main" id="{07E973A5-6BE9-5DF7-CA89-F46B4772FE69}"/>
+              </a:ext>
+            </a:extLst>
+          </p:cNvPr>
+          <p:cNvSpPr>
+            <a:spLocks noGrp="1"/>
+          </p:cNvSpPr>
+          <p:nvPr>
+            <p:ph idx="1"/>
+          </p:nvPr>
+        </p:nvSpPr>
+        <p:spPr/>
+        <p:txBody>
+          <a:bodyPr/>
+          <a:lstStyle/>
+          <a:p>
+            <a:r>
+              <a:rPr lang="en-GB" dirty="0"/>
+              <a:t>Iceberg begins underperforming physical compilation for</a:t>
+            </a:r>
+          </a:p>
+          <a:p>
+            <a:pPr marL="0" indent="0">
+              <a:buNone/>
+            </a:pPr>
+            <a:r>
+              <a:rPr lang="en-GB" dirty="0"/>
+              <a:t>   alpha &gt; 0.04. This corresponds to the following error rates:</a:t>
+            </a:r>
+          </a:p>
+          <a:p>
+            <a:pPr lvl="1"/>
+            <a:r>
+              <a:rPr lang="en-GB" dirty="0"/>
+              <a:t>Qubit initialization error probability (reset) = 0.12%</a:t>
+            </a:r>
+          </a:p>
+          <a:p>
+            <a:pPr lvl="1"/>
+            <a:r>
+              <a:rPr lang="en-GB" dirty="0"/>
+              <a:t>Qubit readout error probability (measure) = 0.12%</a:t>
+            </a:r>
+          </a:p>
+          <a:p>
+            <a:pPr lvl="1"/>
+            <a:r>
+              <a:rPr lang="en-GB" dirty="0"/>
+              <a:t>1-qubit gate error probability = 0.004%</a:t>
+            </a:r>
+          </a:p>
+          <a:p>
+            <a:pPr lvl="1"/>
+            <a:r>
+              <a:rPr lang="en-GB" dirty="0"/>
+              <a:t>2-qubit gate error probability = 0.04%</a:t>
+            </a:r>
+          </a:p>
+        </p:txBody>
+      </p:sp>
+    </p:spTree>
+    <p:extLst>
+      <p:ext uri="{BB962C8B-B14F-4D97-AF65-F5344CB8AC3E}">
+        <p14:creationId xmlns:p14="http://schemas.microsoft.com/office/powerpoint/2010/main" val="713959062"/>
+      </p:ext>
+    </p:extLst>
+  </p:cSld>
+  <p:clrMapOvr>
+    <a:masterClrMapping/>
+  </p:clrMapOvr>
+</p:sld>
+</file>
+
+<file path=ppt/slides/slide28.xml><?xml version="1.0" encoding="utf-8"?>
+<p:sld xmlns:a="http://schemas.openxmlformats.org/drawingml/2006/main" xmlns:r="http://schemas.openxmlformats.org/officeDocument/2006/relationships" xmlns:p="http://schemas.openxmlformats.org/presentationml/2006/main">
+  <p:cSld>
+    <p:spTree>
+      <p:nvGrpSpPr>
+        <p:cNvPr id="1" name=""/>
+        <p:cNvGrpSpPr/>
+        <p:nvPr/>
+      </p:nvGrpSpPr>
+      <p:grpSpPr>
+        <a:xfrm>
+          <a:off x="0" y="0"/>
+          <a:ext cx="0" cy="0"/>
+          <a:chOff x="0" y="0"/>
+          <a:chExt cx="0" cy="0"/>
+        </a:xfrm>
+      </p:grpSpPr>
+      <p:sp>
+        <p:nvSpPr>
+          <p:cNvPr id="2" name="Title 1">
+            <a:extLst>
+              <a:ext uri="{FF2B5EF4-FFF2-40B4-BE49-F238E27FC236}">
+                <a16:creationId xmlns:a16="http://schemas.microsoft.com/office/drawing/2014/main" id="{213F089C-F793-C796-74CB-155494903955}"/>
+              </a:ext>
+            </a:extLst>
+          </p:cNvPr>
+          <p:cNvSpPr>
+            <a:spLocks noGrp="1"/>
+          </p:cNvSpPr>
+          <p:nvPr>
+            <p:ph type="title"/>
+          </p:nvPr>
+        </p:nvSpPr>
+        <p:spPr>
+          <a:xfrm>
+            <a:off x="5070764" y="365125"/>
+            <a:ext cx="6283036" cy="1325563"/>
+          </a:xfrm>
+        </p:spPr>
+        <p:txBody>
+          <a:bodyPr/>
+          <a:lstStyle/>
+          <a:p>
+            <a:r>
+              <a:rPr lang="en-GB" dirty="0"/>
+              <a:t>Implementing Hadamard Test using [[4, 2, 2]]</a:t>
+            </a:r>
+          </a:p>
+        </p:txBody>
+      </p:sp>
+      <p:pic>
+        <p:nvPicPr>
+          <p:cNvPr id="7" name="Picture 6">
+            <a:extLst>
+              <a:ext uri="{FF2B5EF4-FFF2-40B4-BE49-F238E27FC236}">
+                <a16:creationId xmlns:a16="http://schemas.microsoft.com/office/drawing/2014/main" id="{E6FF43C4-6ACF-5411-010E-73AF65CB291E}"/>
+              </a:ext>
+            </a:extLst>
+          </p:cNvPr>
+          <p:cNvPicPr>
+            <a:picLocks noChangeAspect="1"/>
+          </p:cNvPicPr>
+          <p:nvPr/>
+        </p:nvPicPr>
+        <p:blipFill>
+          <a:blip r:embed="rId2"/>
+          <a:stretch>
+            <a:fillRect/>
+          </a:stretch>
+        </p:blipFill>
+        <p:spPr>
+          <a:xfrm>
+            <a:off x="4010891" y="1594228"/>
+            <a:ext cx="8067304" cy="5263772"/>
+          </a:xfrm>
+          <a:prstGeom prst="rect">
+            <a:avLst/>
+          </a:prstGeom>
+        </p:spPr>
+      </p:pic>
+      <p:pic>
+        <p:nvPicPr>
+          <p:cNvPr id="8" name="Picture 7">
+            <a:extLst>
+              <a:ext uri="{FF2B5EF4-FFF2-40B4-BE49-F238E27FC236}">
+                <a16:creationId xmlns:a16="http://schemas.microsoft.com/office/drawing/2014/main" id="{EAA2CE06-3886-226E-25DB-6B9A6A7D0647}"/>
+              </a:ext>
+            </a:extLst>
+          </p:cNvPr>
+          <p:cNvPicPr>
+            <a:picLocks noChangeAspect="1"/>
+          </p:cNvPicPr>
+          <p:nvPr/>
+        </p:nvPicPr>
+        <p:blipFill>
+          <a:blip r:embed="rId3"/>
+          <a:stretch>
+            <a:fillRect/>
+          </a:stretch>
+        </p:blipFill>
+        <p:spPr>
+          <a:xfrm>
+            <a:off x="321623" y="98426"/>
+            <a:ext cx="4608068" cy="1762502"/>
+          </a:xfrm>
+          <a:prstGeom prst="rect">
+            <a:avLst/>
+          </a:prstGeom>
+        </p:spPr>
+      </p:pic>
+    </p:spTree>
+    <p:extLst>
+      <p:ext uri="{BB962C8B-B14F-4D97-AF65-F5344CB8AC3E}">
+        <p14:creationId xmlns:p14="http://schemas.microsoft.com/office/powerpoint/2010/main" val="2140056534"/>
+      </p:ext>
+    </p:extLst>
+  </p:cSld>
+  <p:clrMapOvr>
+    <a:masterClrMapping/>
+  </p:clrMapOvr>
+</p:sld>
+</file>
+
+<file path=ppt/slides/slide29.xml><?xml version="1.0" encoding="utf-8"?>
+<p:sld xmlns:a="http://schemas.openxmlformats.org/drawingml/2006/main" xmlns:r="http://schemas.openxmlformats.org/officeDocument/2006/relationships" xmlns:p="http://schemas.openxmlformats.org/presentationml/2006/main">
+  <p:cSld>
+    <p:spTree>
+      <p:nvGrpSpPr>
+        <p:cNvPr id="1" name=""/>
+        <p:cNvGrpSpPr/>
+        <p:nvPr/>
+      </p:nvGrpSpPr>
+      <p:grpSpPr>
+        <a:xfrm>
+          <a:off x="0" y="0"/>
+          <a:ext cx="0" cy="0"/>
+          <a:chOff x="0" y="0"/>
+          <a:chExt cx="0" cy="0"/>
+        </a:xfrm>
+      </p:grpSpPr>
+      <p:sp>
+        <p:nvSpPr>
+          <p:cNvPr id="2" name="Title 1">
+            <a:extLst>
+              <a:ext uri="{FF2B5EF4-FFF2-40B4-BE49-F238E27FC236}">
+                <a16:creationId xmlns:a16="http://schemas.microsoft.com/office/drawing/2014/main" id="{4494FE98-D17E-AABB-9A0E-6D7CA690B216}"/>
+              </a:ext>
+            </a:extLst>
+          </p:cNvPr>
+          <p:cNvSpPr>
+            <a:spLocks noGrp="1"/>
+          </p:cNvSpPr>
+          <p:nvPr>
+            <p:ph type="title"/>
+          </p:nvPr>
+        </p:nvSpPr>
+        <p:spPr/>
+        <p:txBody>
+          <a:bodyPr/>
+          <a:lstStyle/>
+          <a:p>
+            <a:r>
+              <a:rPr lang="en-GB" dirty="0"/>
+              <a:t>Questions</a:t>
+            </a:r>
+          </a:p>
+        </p:txBody>
+      </p:sp>
+      <p:sp>
+        <p:nvSpPr>
+          <p:cNvPr id="3" name="Content Placeholder 2">
+            <a:extLst>
+              <a:ext uri="{FF2B5EF4-FFF2-40B4-BE49-F238E27FC236}">
+                <a16:creationId xmlns:a16="http://schemas.microsoft.com/office/drawing/2014/main" id="{351C3A8D-49BE-E11C-9D80-8B22EEAFC895}"/>
+              </a:ext>
+            </a:extLst>
+          </p:cNvPr>
+          <p:cNvSpPr>
+            <a:spLocks noGrp="1"/>
+          </p:cNvSpPr>
+          <p:nvPr>
+            <p:ph idx="1"/>
+          </p:nvPr>
+        </p:nvSpPr>
+        <p:spPr/>
+        <p:txBody>
+          <a:bodyPr/>
+          <a:lstStyle/>
+          <a:p>
+            <a:r>
+              <a:rPr lang="en-GB" dirty="0"/>
+              <a:t>What about the movement that is needed for the final decoding step?</a:t>
+            </a:r>
+          </a:p>
+          <a:p>
+            <a:endParaRPr lang="en-GB" dirty="0"/>
+          </a:p>
+          <a:p>
+            <a:r>
+              <a:rPr lang="en-GB" dirty="0"/>
+              <a:t>What is the difference between version 1 and 2 of the </a:t>
+            </a:r>
+            <a:r>
+              <a:rPr lang="en-GB"/>
+              <a:t>circuits?</a:t>
+            </a:r>
+            <a:endParaRPr lang="en-GB" dirty="0"/>
+          </a:p>
+        </p:txBody>
+      </p:sp>
+    </p:spTree>
+    <p:extLst>
+      <p:ext uri="{BB962C8B-B14F-4D97-AF65-F5344CB8AC3E}">
+        <p14:creationId xmlns:p14="http://schemas.microsoft.com/office/powerpoint/2010/main" val="2645722377"/>
       </p:ext>
     </p:extLst>
   </p:cSld>

</xml_diff>

<commit_message>
Implemented v2 of Hadamard test; added comments for better readability in generalized_shor.py
</commit_message>
<xml_diff>
--- a/direction.pptx
+++ b/direction.pptx
@@ -34,6 +34,9 @@
     <p:sldId id="283" r:id="rId28"/>
     <p:sldId id="284" r:id="rId29"/>
     <p:sldId id="285" r:id="rId30"/>
+    <p:sldId id="287" r:id="rId31"/>
+    <p:sldId id="286" r:id="rId32"/>
+    <p:sldId id="288" r:id="rId33"/>
   </p:sldIdLst>
   <p:sldSz cx="12192000" cy="6858000"/>
   <p:notesSz cx="6858000" cy="9144000"/>
@@ -289,7 +292,7 @@
           <a:p>
             <a:fld id="{B74604FD-B602-FC49-9746-E8C71C959787}" type="datetimeFigureOut">
               <a:rPr lang="en-US" smtClean="0"/>
-              <a:t>5/9/25</a:t>
+              <a:t>5/15/25</a:t>
             </a:fld>
             <a:endParaRPr lang="en-US"/>
           </a:p>
@@ -489,7 +492,7 @@
           <a:p>
             <a:fld id="{B74604FD-B602-FC49-9746-E8C71C959787}" type="datetimeFigureOut">
               <a:rPr lang="en-US" smtClean="0"/>
-              <a:t>5/9/25</a:t>
+              <a:t>5/15/25</a:t>
             </a:fld>
             <a:endParaRPr lang="en-US"/>
           </a:p>
@@ -699,7 +702,7 @@
           <a:p>
             <a:fld id="{B74604FD-B602-FC49-9746-E8C71C959787}" type="datetimeFigureOut">
               <a:rPr lang="en-US" smtClean="0"/>
-              <a:t>5/9/25</a:t>
+              <a:t>5/15/25</a:t>
             </a:fld>
             <a:endParaRPr lang="en-US"/>
           </a:p>
@@ -899,7 +902,7 @@
           <a:p>
             <a:fld id="{B74604FD-B602-FC49-9746-E8C71C959787}" type="datetimeFigureOut">
               <a:rPr lang="en-US" smtClean="0"/>
-              <a:t>5/9/25</a:t>
+              <a:t>5/15/25</a:t>
             </a:fld>
             <a:endParaRPr lang="en-US"/>
           </a:p>
@@ -1175,7 +1178,7 @@
           <a:p>
             <a:fld id="{B74604FD-B602-FC49-9746-E8C71C959787}" type="datetimeFigureOut">
               <a:rPr lang="en-US" smtClean="0"/>
-              <a:t>5/9/25</a:t>
+              <a:t>5/15/25</a:t>
             </a:fld>
             <a:endParaRPr lang="en-US"/>
           </a:p>
@@ -1443,7 +1446,7 @@
           <a:p>
             <a:fld id="{B74604FD-B602-FC49-9746-E8C71C959787}" type="datetimeFigureOut">
               <a:rPr lang="en-US" smtClean="0"/>
-              <a:t>5/9/25</a:t>
+              <a:t>5/15/25</a:t>
             </a:fld>
             <a:endParaRPr lang="en-US"/>
           </a:p>
@@ -1858,7 +1861,7 @@
           <a:p>
             <a:fld id="{B74604FD-B602-FC49-9746-E8C71C959787}" type="datetimeFigureOut">
               <a:rPr lang="en-US" smtClean="0"/>
-              <a:t>5/9/25</a:t>
+              <a:t>5/15/25</a:t>
             </a:fld>
             <a:endParaRPr lang="en-US"/>
           </a:p>
@@ -2000,7 +2003,7 @@
           <a:p>
             <a:fld id="{B74604FD-B602-FC49-9746-E8C71C959787}" type="datetimeFigureOut">
               <a:rPr lang="en-US" smtClean="0"/>
-              <a:t>5/9/25</a:t>
+              <a:t>5/15/25</a:t>
             </a:fld>
             <a:endParaRPr lang="en-US"/>
           </a:p>
@@ -2113,7 +2116,7 @@
           <a:p>
             <a:fld id="{B74604FD-B602-FC49-9746-E8C71C959787}" type="datetimeFigureOut">
               <a:rPr lang="en-US" smtClean="0"/>
-              <a:t>5/9/25</a:t>
+              <a:t>5/15/25</a:t>
             </a:fld>
             <a:endParaRPr lang="en-US"/>
           </a:p>
@@ -2426,7 +2429,7 @@
           <a:p>
             <a:fld id="{B74604FD-B602-FC49-9746-E8C71C959787}" type="datetimeFigureOut">
               <a:rPr lang="en-US" smtClean="0"/>
-              <a:t>5/9/25</a:t>
+              <a:t>5/15/25</a:t>
             </a:fld>
             <a:endParaRPr lang="en-US"/>
           </a:p>
@@ -2715,7 +2718,7 @@
           <a:p>
             <a:fld id="{B74604FD-B602-FC49-9746-E8C71C959787}" type="datetimeFigureOut">
               <a:rPr lang="en-US" smtClean="0"/>
-              <a:t>5/9/25</a:t>
+              <a:t>5/15/25</a:t>
             </a:fld>
             <a:endParaRPr lang="en-US"/>
           </a:p>
@@ -2958,7 +2961,7 @@
           <a:p>
             <a:fld id="{B74604FD-B602-FC49-9746-E8C71C959787}" type="datetimeFigureOut">
               <a:rPr lang="en-US" smtClean="0"/>
-              <a:t>5/9/25</a:t>
+              <a:t>5/15/25</a:t>
             </a:fld>
             <a:endParaRPr lang="en-US"/>
           </a:p>
@@ -3439,11 +3442,11 @@
           <a:p>
             <a:r>
               <a:rPr lang="en-US" dirty="0"/>
-              <a:t>Sayam Sethi, Maxwell Poster, Aditi Awasthi, Ali </a:t>
-            </a:r>
-            <a:r>
-              <a:rPr lang="en-US" dirty="0" err="1"/>
-              <a:t>Khamseen</a:t>
+              <a:t>Sayam Sethi, Maxwell Poster, </a:t>
+            </a:r>
+            <a:r>
+              <a:rPr lang="en-US"/>
+              <a:t>Aditi Awasthi</a:t>
             </a:r>
             <a:endParaRPr lang="en-US" dirty="0"/>
           </a:p>
@@ -6755,6 +6758,441 @@
     <p:extLst>
       <p:ext uri="{BB962C8B-B14F-4D97-AF65-F5344CB8AC3E}">
         <p14:creationId xmlns:p14="http://schemas.microsoft.com/office/powerpoint/2010/main" val="264443973"/>
+      </p:ext>
+    </p:extLst>
+  </p:cSld>
+  <p:clrMapOvr>
+    <a:masterClrMapping/>
+  </p:clrMapOvr>
+</p:sld>
+</file>
+
+<file path=ppt/slides/slide30.xml><?xml version="1.0" encoding="utf-8"?>
+<p:sld xmlns:a="http://schemas.openxmlformats.org/drawingml/2006/main" xmlns:r="http://schemas.openxmlformats.org/officeDocument/2006/relationships" xmlns:p="http://schemas.openxmlformats.org/presentationml/2006/main">
+  <p:cSld>
+    <p:spTree>
+      <p:nvGrpSpPr>
+        <p:cNvPr id="1" name=""/>
+        <p:cNvGrpSpPr/>
+        <p:nvPr/>
+      </p:nvGrpSpPr>
+      <p:grpSpPr>
+        <a:xfrm>
+          <a:off x="0" y="0"/>
+          <a:ext cx="0" cy="0"/>
+          <a:chOff x="0" y="0"/>
+          <a:chExt cx="0" cy="0"/>
+        </a:xfrm>
+      </p:grpSpPr>
+      <p:sp>
+        <p:nvSpPr>
+          <p:cNvPr id="2" name="Title 1">
+            <a:extLst>
+              <a:ext uri="{FF2B5EF4-FFF2-40B4-BE49-F238E27FC236}">
+                <a16:creationId xmlns:a16="http://schemas.microsoft.com/office/drawing/2014/main" id="{0A74B499-FD9E-0FB7-1F30-046427858341}"/>
+              </a:ext>
+            </a:extLst>
+          </p:cNvPr>
+          <p:cNvSpPr>
+            <a:spLocks noGrp="1"/>
+          </p:cNvSpPr>
+          <p:nvPr>
+            <p:ph type="title"/>
+          </p:nvPr>
+        </p:nvSpPr>
+        <p:spPr>
+          <a:xfrm>
+            <a:off x="838200" y="18255"/>
+            <a:ext cx="10515600" cy="1325563"/>
+          </a:xfrm>
+        </p:spPr>
+        <p:txBody>
+          <a:bodyPr/>
+          <a:lstStyle/>
+          <a:p>
+            <a:r>
+              <a:rPr lang="en-GB" dirty="0"/>
+              <a:t>Correction/Update from Last Week</a:t>
+            </a:r>
+          </a:p>
+        </p:txBody>
+      </p:sp>
+      <p:sp>
+        <p:nvSpPr>
+          <p:cNvPr id="3" name="Content Placeholder 2">
+            <a:extLst>
+              <a:ext uri="{FF2B5EF4-FFF2-40B4-BE49-F238E27FC236}">
+                <a16:creationId xmlns:a16="http://schemas.microsoft.com/office/drawing/2014/main" id="{4BC3D364-C29C-EADB-A40A-DF45E94418A7}"/>
+              </a:ext>
+            </a:extLst>
+          </p:cNvPr>
+          <p:cNvSpPr>
+            <a:spLocks noGrp="1"/>
+          </p:cNvSpPr>
+          <p:nvPr>
+            <p:ph idx="1"/>
+          </p:nvPr>
+        </p:nvSpPr>
+        <p:spPr>
+          <a:xfrm>
+            <a:off x="838200" y="1343818"/>
+            <a:ext cx="10515600" cy="4833145"/>
+          </a:xfrm>
+        </p:spPr>
+        <p:txBody>
+          <a:bodyPr/>
+          <a:lstStyle/>
+          <a:p>
+            <a:r>
+              <a:rPr lang="en-GB" dirty="0"/>
+              <a:t>The output shown last week was an artifact of low shot rate coupled with </a:t>
+            </a:r>
+            <a:r>
+              <a:rPr lang="en-GB"/>
+              <a:t>low post-selection </a:t>
+            </a:r>
+            <a:r>
+              <a:rPr lang="en-GB" dirty="0"/>
+              <a:t>success</a:t>
+            </a:r>
+          </a:p>
+        </p:txBody>
+      </p:sp>
+      <p:pic>
+        <p:nvPicPr>
+          <p:cNvPr id="5" name="Picture 4">
+            <a:extLst>
+              <a:ext uri="{FF2B5EF4-FFF2-40B4-BE49-F238E27FC236}">
+                <a16:creationId xmlns:a16="http://schemas.microsoft.com/office/drawing/2014/main" id="{7AFD5A04-C351-9B67-AC38-CC976141A5A5}"/>
+              </a:ext>
+            </a:extLst>
+          </p:cNvPr>
+          <p:cNvPicPr>
+            <a:picLocks noChangeAspect="1"/>
+          </p:cNvPicPr>
+          <p:nvPr/>
+        </p:nvPicPr>
+        <p:blipFill>
+          <a:blip r:embed="rId2"/>
+          <a:stretch>
+            <a:fillRect/>
+          </a:stretch>
+        </p:blipFill>
+        <p:spPr>
+          <a:xfrm>
+            <a:off x="4089400" y="2099853"/>
+            <a:ext cx="7264400" cy="4739892"/>
+          </a:xfrm>
+          <a:prstGeom prst="rect">
+            <a:avLst/>
+          </a:prstGeom>
+        </p:spPr>
+      </p:pic>
+      <p:pic>
+        <p:nvPicPr>
+          <p:cNvPr id="6" name="Picture 5">
+            <a:extLst>
+              <a:ext uri="{FF2B5EF4-FFF2-40B4-BE49-F238E27FC236}">
+                <a16:creationId xmlns:a16="http://schemas.microsoft.com/office/drawing/2014/main" id="{D738BCE2-391C-390C-DB24-82B1B314335B}"/>
+              </a:ext>
+            </a:extLst>
+          </p:cNvPr>
+          <p:cNvPicPr>
+            <a:picLocks noChangeAspect="1"/>
+          </p:cNvPicPr>
+          <p:nvPr/>
+        </p:nvPicPr>
+        <p:blipFill>
+          <a:blip r:embed="rId3"/>
+          <a:stretch>
+            <a:fillRect/>
+          </a:stretch>
+        </p:blipFill>
+        <p:spPr>
+          <a:xfrm>
+            <a:off x="70636" y="2892010"/>
+            <a:ext cx="4018764" cy="2622172"/>
+          </a:xfrm>
+          <a:prstGeom prst="rect">
+            <a:avLst/>
+          </a:prstGeom>
+        </p:spPr>
+      </p:pic>
+    </p:spTree>
+    <p:extLst>
+      <p:ext uri="{BB962C8B-B14F-4D97-AF65-F5344CB8AC3E}">
+        <p14:creationId xmlns:p14="http://schemas.microsoft.com/office/powerpoint/2010/main" val="20091179"/>
+      </p:ext>
+    </p:extLst>
+  </p:cSld>
+  <p:clrMapOvr>
+    <a:masterClrMapping/>
+  </p:clrMapOvr>
+</p:sld>
+</file>
+
+<file path=ppt/slides/slide31.xml><?xml version="1.0" encoding="utf-8"?>
+<p:sld xmlns:a="http://schemas.openxmlformats.org/drawingml/2006/main" xmlns:r="http://schemas.openxmlformats.org/officeDocument/2006/relationships" xmlns:p="http://schemas.openxmlformats.org/presentationml/2006/main">
+  <p:cSld>
+    <p:spTree>
+      <p:nvGrpSpPr>
+        <p:cNvPr id="1" name=""/>
+        <p:cNvGrpSpPr/>
+        <p:nvPr/>
+      </p:nvGrpSpPr>
+      <p:grpSpPr>
+        <a:xfrm>
+          <a:off x="0" y="0"/>
+          <a:ext cx="0" cy="0"/>
+          <a:chOff x="0" y="0"/>
+          <a:chExt cx="0" cy="0"/>
+        </a:xfrm>
+      </p:grpSpPr>
+      <p:sp>
+        <p:nvSpPr>
+          <p:cNvPr id="2" name="Title 1">
+            <a:extLst>
+              <a:ext uri="{FF2B5EF4-FFF2-40B4-BE49-F238E27FC236}">
+                <a16:creationId xmlns:a16="http://schemas.microsoft.com/office/drawing/2014/main" id="{2F80CB3C-0641-B2A1-7A0F-03AF25D07894}"/>
+              </a:ext>
+            </a:extLst>
+          </p:cNvPr>
+          <p:cNvSpPr>
+            <a:spLocks noGrp="1"/>
+          </p:cNvSpPr>
+          <p:nvPr>
+            <p:ph type="title"/>
+          </p:nvPr>
+        </p:nvSpPr>
+        <p:spPr/>
+        <p:txBody>
+          <a:bodyPr/>
+          <a:lstStyle/>
+          <a:p>
+            <a:r>
+              <a:rPr lang="en-GB" dirty="0"/>
+              <a:t>Second version of Hadamard Test</a:t>
+            </a:r>
+          </a:p>
+        </p:txBody>
+      </p:sp>
+      <p:pic>
+        <p:nvPicPr>
+          <p:cNvPr id="4" name="Picture 3">
+            <a:extLst>
+              <a:ext uri="{FF2B5EF4-FFF2-40B4-BE49-F238E27FC236}">
+                <a16:creationId xmlns:a16="http://schemas.microsoft.com/office/drawing/2014/main" id="{FB681FBB-F73E-ACFE-F555-A1E11AA85D6F}"/>
+              </a:ext>
+            </a:extLst>
+          </p:cNvPr>
+          <p:cNvPicPr>
+            <a:picLocks noChangeAspect="1"/>
+          </p:cNvPicPr>
+          <p:nvPr/>
+        </p:nvPicPr>
+        <p:blipFill>
+          <a:blip r:embed="rId2"/>
+          <a:stretch>
+            <a:fillRect/>
+          </a:stretch>
+        </p:blipFill>
+        <p:spPr>
+          <a:xfrm>
+            <a:off x="476250" y="1474787"/>
+            <a:ext cx="7943850" cy="5183221"/>
+          </a:xfrm>
+          <a:prstGeom prst="rect">
+            <a:avLst/>
+          </a:prstGeom>
+        </p:spPr>
+      </p:pic>
+      <p:pic>
+        <p:nvPicPr>
+          <p:cNvPr id="5" name="Picture 4">
+            <a:extLst>
+              <a:ext uri="{FF2B5EF4-FFF2-40B4-BE49-F238E27FC236}">
+                <a16:creationId xmlns:a16="http://schemas.microsoft.com/office/drawing/2014/main" id="{5CDDA779-4B87-E5AB-2AF9-DC6FE8374FF6}"/>
+              </a:ext>
+            </a:extLst>
+          </p:cNvPr>
+          <p:cNvPicPr>
+            <a:picLocks noChangeAspect="1"/>
+          </p:cNvPicPr>
+          <p:nvPr/>
+        </p:nvPicPr>
+        <p:blipFill>
+          <a:blip r:embed="rId3"/>
+          <a:stretch>
+            <a:fillRect/>
+          </a:stretch>
+        </p:blipFill>
+        <p:spPr>
+          <a:xfrm>
+            <a:off x="8782050" y="0"/>
+            <a:ext cx="3263900" cy="2473336"/>
+          </a:xfrm>
+          <a:prstGeom prst="rect">
+            <a:avLst/>
+          </a:prstGeom>
+        </p:spPr>
+      </p:pic>
+      <p:sp>
+        <p:nvSpPr>
+          <p:cNvPr id="6" name="TextBox 5">
+            <a:extLst>
+              <a:ext uri="{FF2B5EF4-FFF2-40B4-BE49-F238E27FC236}">
+                <a16:creationId xmlns:a16="http://schemas.microsoft.com/office/drawing/2014/main" id="{8E22569B-EDBB-052E-4C7C-313EB9EE4F6C}"/>
+              </a:ext>
+            </a:extLst>
+          </p:cNvPr>
+          <p:cNvSpPr txBox="1"/>
+          <p:nvPr/>
+        </p:nvSpPr>
+        <p:spPr>
+          <a:xfrm>
+            <a:off x="8420100" y="3604732"/>
+            <a:ext cx="3694257" cy="923330"/>
+          </a:xfrm>
+          <a:prstGeom prst="rect">
+            <a:avLst/>
+          </a:prstGeom>
+          <a:noFill/>
+        </p:spPr>
+        <p:txBody>
+          <a:bodyPr wrap="square" rtlCol="0">
+            <a:spAutoFit/>
+          </a:bodyPr>
+          <a:lstStyle/>
+          <a:p>
+            <a:r>
+              <a:rPr lang="en-GB" dirty="0"/>
+              <a:t>Expected output is uniform superposition over qubits 1, 3, 4 but qubit 2 is always in the 0 state.</a:t>
+            </a:r>
+          </a:p>
+        </p:txBody>
+      </p:sp>
+    </p:spTree>
+    <p:extLst>
+      <p:ext uri="{BB962C8B-B14F-4D97-AF65-F5344CB8AC3E}">
+        <p14:creationId xmlns:p14="http://schemas.microsoft.com/office/powerpoint/2010/main" val="2499215127"/>
+      </p:ext>
+    </p:extLst>
+  </p:cSld>
+  <p:clrMapOvr>
+    <a:masterClrMapping/>
+  </p:clrMapOvr>
+</p:sld>
+</file>
+
+<file path=ppt/slides/slide32.xml><?xml version="1.0" encoding="utf-8"?>
+<p:sld xmlns:a="http://schemas.openxmlformats.org/drawingml/2006/main" xmlns:r="http://schemas.openxmlformats.org/officeDocument/2006/relationships" xmlns:p="http://schemas.openxmlformats.org/presentationml/2006/main">
+  <p:cSld>
+    <p:spTree>
+      <p:nvGrpSpPr>
+        <p:cNvPr id="1" name=""/>
+        <p:cNvGrpSpPr/>
+        <p:nvPr/>
+      </p:nvGrpSpPr>
+      <p:grpSpPr>
+        <a:xfrm>
+          <a:off x="0" y="0"/>
+          <a:ext cx="0" cy="0"/>
+          <a:chOff x="0" y="0"/>
+          <a:chExt cx="0" cy="0"/>
+        </a:xfrm>
+      </p:grpSpPr>
+      <p:sp>
+        <p:nvSpPr>
+          <p:cNvPr id="2" name="Title 1">
+            <a:extLst>
+              <a:ext uri="{FF2B5EF4-FFF2-40B4-BE49-F238E27FC236}">
+                <a16:creationId xmlns:a16="http://schemas.microsoft.com/office/drawing/2014/main" id="{64817321-986E-5A57-B090-62B1B9A4AFF9}"/>
+              </a:ext>
+            </a:extLst>
+          </p:cNvPr>
+          <p:cNvSpPr>
+            <a:spLocks noGrp="1"/>
+          </p:cNvSpPr>
+          <p:nvPr>
+            <p:ph type="title"/>
+          </p:nvPr>
+        </p:nvSpPr>
+        <p:spPr/>
+        <p:txBody>
+          <a:bodyPr/>
+          <a:lstStyle/>
+          <a:p>
+            <a:r>
+              <a:rPr lang="en-GB" dirty="0"/>
+              <a:t>How to enforce Fault-Tolerance?</a:t>
+            </a:r>
+          </a:p>
+        </p:txBody>
+      </p:sp>
+      <p:pic>
+        <p:nvPicPr>
+          <p:cNvPr id="5" name="Picture 4">
+            <a:extLst>
+              <a:ext uri="{FF2B5EF4-FFF2-40B4-BE49-F238E27FC236}">
+                <a16:creationId xmlns:a16="http://schemas.microsoft.com/office/drawing/2014/main" id="{74C58CB6-4A38-B9CF-5BC0-9FFCDE92937F}"/>
+              </a:ext>
+            </a:extLst>
+          </p:cNvPr>
+          <p:cNvPicPr>
+            <a:picLocks noChangeAspect="1"/>
+          </p:cNvPicPr>
+          <p:nvPr/>
+        </p:nvPicPr>
+        <p:blipFill>
+          <a:blip r:embed="rId2"/>
+          <a:stretch>
+            <a:fillRect/>
+          </a:stretch>
+        </p:blipFill>
+        <p:spPr>
+          <a:xfrm>
+            <a:off x="5486399" y="1863880"/>
+            <a:ext cx="6160281" cy="4409649"/>
+          </a:xfrm>
+          <a:prstGeom prst="rect">
+            <a:avLst/>
+          </a:prstGeom>
+        </p:spPr>
+      </p:pic>
+      <p:pic>
+        <p:nvPicPr>
+          <p:cNvPr id="6" name="Picture 5">
+            <a:extLst>
+              <a:ext uri="{FF2B5EF4-FFF2-40B4-BE49-F238E27FC236}">
+                <a16:creationId xmlns:a16="http://schemas.microsoft.com/office/drawing/2014/main" id="{3ED6A2C6-12F5-94FF-AF9D-DE35BFFF1AFF}"/>
+              </a:ext>
+            </a:extLst>
+          </p:cNvPr>
+          <p:cNvPicPr>
+            <a:picLocks noChangeAspect="1"/>
+          </p:cNvPicPr>
+          <p:nvPr/>
+        </p:nvPicPr>
+        <p:blipFill>
+          <a:blip r:embed="rId3"/>
+          <a:stretch>
+            <a:fillRect/>
+          </a:stretch>
+        </p:blipFill>
+        <p:spPr>
+          <a:xfrm>
+            <a:off x="838200" y="2805412"/>
+            <a:ext cx="4545329" cy="2526586"/>
+          </a:xfrm>
+          <a:prstGeom prst="rect">
+            <a:avLst/>
+          </a:prstGeom>
+        </p:spPr>
+      </p:pic>
+    </p:spTree>
+    <p:extLst>
+      <p:ext uri="{BB962C8B-B14F-4D97-AF65-F5344CB8AC3E}">
+        <p14:creationId xmlns:p14="http://schemas.microsoft.com/office/powerpoint/2010/main" val="3646509164"/>
       </p:ext>
     </p:extLst>
   </p:cSld>

</xml_diff>

<commit_message>
Added requirements.txt; v2 of Hadamard test circuit; renamed (i)py(nb) file to experiments.py (#5)
* Added CZ, S, decode, measure to iceberg

formatted random_circuit_gen; fixed environ import in generalized_shor

* Moved random_circuit_gen to circuits; added code to compare resilience of iceberg vs physical compilation

* improved random_circuit_gen script

* Added IcebergGrid class and improved inheritance structure

* Ran initial Hadamard test experiments

* Cleaned up generalized_shor.py

* Implemented v2 of Hadamard test; added comments for better readability in generalized_shor.py

* Renamed generalized_shor to experiments
</commit_message>
<xml_diff>
--- a/direction.pptx
+++ b/direction.pptx
@@ -34,6 +34,9 @@
     <p:sldId id="283" r:id="rId28"/>
     <p:sldId id="284" r:id="rId29"/>
     <p:sldId id="285" r:id="rId30"/>
+    <p:sldId id="287" r:id="rId31"/>
+    <p:sldId id="286" r:id="rId32"/>
+    <p:sldId id="288" r:id="rId33"/>
   </p:sldIdLst>
   <p:sldSz cx="12192000" cy="6858000"/>
   <p:notesSz cx="6858000" cy="9144000"/>
@@ -289,7 +292,7 @@
           <a:p>
             <a:fld id="{B74604FD-B602-FC49-9746-E8C71C959787}" type="datetimeFigureOut">
               <a:rPr lang="en-US" smtClean="0"/>
-              <a:t>5/9/25</a:t>
+              <a:t>5/15/25</a:t>
             </a:fld>
             <a:endParaRPr lang="en-US"/>
           </a:p>
@@ -489,7 +492,7 @@
           <a:p>
             <a:fld id="{B74604FD-B602-FC49-9746-E8C71C959787}" type="datetimeFigureOut">
               <a:rPr lang="en-US" smtClean="0"/>
-              <a:t>5/9/25</a:t>
+              <a:t>5/15/25</a:t>
             </a:fld>
             <a:endParaRPr lang="en-US"/>
           </a:p>
@@ -699,7 +702,7 @@
           <a:p>
             <a:fld id="{B74604FD-B602-FC49-9746-E8C71C959787}" type="datetimeFigureOut">
               <a:rPr lang="en-US" smtClean="0"/>
-              <a:t>5/9/25</a:t>
+              <a:t>5/15/25</a:t>
             </a:fld>
             <a:endParaRPr lang="en-US"/>
           </a:p>
@@ -899,7 +902,7 @@
           <a:p>
             <a:fld id="{B74604FD-B602-FC49-9746-E8C71C959787}" type="datetimeFigureOut">
               <a:rPr lang="en-US" smtClean="0"/>
-              <a:t>5/9/25</a:t>
+              <a:t>5/15/25</a:t>
             </a:fld>
             <a:endParaRPr lang="en-US"/>
           </a:p>
@@ -1175,7 +1178,7 @@
           <a:p>
             <a:fld id="{B74604FD-B602-FC49-9746-E8C71C959787}" type="datetimeFigureOut">
               <a:rPr lang="en-US" smtClean="0"/>
-              <a:t>5/9/25</a:t>
+              <a:t>5/15/25</a:t>
             </a:fld>
             <a:endParaRPr lang="en-US"/>
           </a:p>
@@ -1443,7 +1446,7 @@
           <a:p>
             <a:fld id="{B74604FD-B602-FC49-9746-E8C71C959787}" type="datetimeFigureOut">
               <a:rPr lang="en-US" smtClean="0"/>
-              <a:t>5/9/25</a:t>
+              <a:t>5/15/25</a:t>
             </a:fld>
             <a:endParaRPr lang="en-US"/>
           </a:p>
@@ -1858,7 +1861,7 @@
           <a:p>
             <a:fld id="{B74604FD-B602-FC49-9746-E8C71C959787}" type="datetimeFigureOut">
               <a:rPr lang="en-US" smtClean="0"/>
-              <a:t>5/9/25</a:t>
+              <a:t>5/15/25</a:t>
             </a:fld>
             <a:endParaRPr lang="en-US"/>
           </a:p>
@@ -2000,7 +2003,7 @@
           <a:p>
             <a:fld id="{B74604FD-B602-FC49-9746-E8C71C959787}" type="datetimeFigureOut">
               <a:rPr lang="en-US" smtClean="0"/>
-              <a:t>5/9/25</a:t>
+              <a:t>5/15/25</a:t>
             </a:fld>
             <a:endParaRPr lang="en-US"/>
           </a:p>
@@ -2113,7 +2116,7 @@
           <a:p>
             <a:fld id="{B74604FD-B602-FC49-9746-E8C71C959787}" type="datetimeFigureOut">
               <a:rPr lang="en-US" smtClean="0"/>
-              <a:t>5/9/25</a:t>
+              <a:t>5/15/25</a:t>
             </a:fld>
             <a:endParaRPr lang="en-US"/>
           </a:p>
@@ -2426,7 +2429,7 @@
           <a:p>
             <a:fld id="{B74604FD-B602-FC49-9746-E8C71C959787}" type="datetimeFigureOut">
               <a:rPr lang="en-US" smtClean="0"/>
-              <a:t>5/9/25</a:t>
+              <a:t>5/15/25</a:t>
             </a:fld>
             <a:endParaRPr lang="en-US"/>
           </a:p>
@@ -2715,7 +2718,7 @@
           <a:p>
             <a:fld id="{B74604FD-B602-FC49-9746-E8C71C959787}" type="datetimeFigureOut">
               <a:rPr lang="en-US" smtClean="0"/>
-              <a:t>5/9/25</a:t>
+              <a:t>5/15/25</a:t>
             </a:fld>
             <a:endParaRPr lang="en-US"/>
           </a:p>
@@ -2958,7 +2961,7 @@
           <a:p>
             <a:fld id="{B74604FD-B602-FC49-9746-E8C71C959787}" type="datetimeFigureOut">
               <a:rPr lang="en-US" smtClean="0"/>
-              <a:t>5/9/25</a:t>
+              <a:t>5/15/25</a:t>
             </a:fld>
             <a:endParaRPr lang="en-US"/>
           </a:p>
@@ -3439,11 +3442,11 @@
           <a:p>
             <a:r>
               <a:rPr lang="en-US" dirty="0"/>
-              <a:t>Sayam Sethi, Maxwell Poster, Aditi Awasthi, Ali </a:t>
-            </a:r>
-            <a:r>
-              <a:rPr lang="en-US" dirty="0" err="1"/>
-              <a:t>Khamseen</a:t>
+              <a:t>Sayam Sethi, Maxwell Poster, </a:t>
+            </a:r>
+            <a:r>
+              <a:rPr lang="en-US"/>
+              <a:t>Aditi Awasthi</a:t>
             </a:r>
             <a:endParaRPr lang="en-US" dirty="0"/>
           </a:p>
@@ -6755,6 +6758,441 @@
     <p:extLst>
       <p:ext uri="{BB962C8B-B14F-4D97-AF65-F5344CB8AC3E}">
         <p14:creationId xmlns:p14="http://schemas.microsoft.com/office/powerpoint/2010/main" val="264443973"/>
+      </p:ext>
+    </p:extLst>
+  </p:cSld>
+  <p:clrMapOvr>
+    <a:masterClrMapping/>
+  </p:clrMapOvr>
+</p:sld>
+</file>
+
+<file path=ppt/slides/slide30.xml><?xml version="1.0" encoding="utf-8"?>
+<p:sld xmlns:a="http://schemas.openxmlformats.org/drawingml/2006/main" xmlns:r="http://schemas.openxmlformats.org/officeDocument/2006/relationships" xmlns:p="http://schemas.openxmlformats.org/presentationml/2006/main">
+  <p:cSld>
+    <p:spTree>
+      <p:nvGrpSpPr>
+        <p:cNvPr id="1" name=""/>
+        <p:cNvGrpSpPr/>
+        <p:nvPr/>
+      </p:nvGrpSpPr>
+      <p:grpSpPr>
+        <a:xfrm>
+          <a:off x="0" y="0"/>
+          <a:ext cx="0" cy="0"/>
+          <a:chOff x="0" y="0"/>
+          <a:chExt cx="0" cy="0"/>
+        </a:xfrm>
+      </p:grpSpPr>
+      <p:sp>
+        <p:nvSpPr>
+          <p:cNvPr id="2" name="Title 1">
+            <a:extLst>
+              <a:ext uri="{FF2B5EF4-FFF2-40B4-BE49-F238E27FC236}">
+                <a16:creationId xmlns:a16="http://schemas.microsoft.com/office/drawing/2014/main" id="{0A74B499-FD9E-0FB7-1F30-046427858341}"/>
+              </a:ext>
+            </a:extLst>
+          </p:cNvPr>
+          <p:cNvSpPr>
+            <a:spLocks noGrp="1"/>
+          </p:cNvSpPr>
+          <p:nvPr>
+            <p:ph type="title"/>
+          </p:nvPr>
+        </p:nvSpPr>
+        <p:spPr>
+          <a:xfrm>
+            <a:off x="838200" y="18255"/>
+            <a:ext cx="10515600" cy="1325563"/>
+          </a:xfrm>
+        </p:spPr>
+        <p:txBody>
+          <a:bodyPr/>
+          <a:lstStyle/>
+          <a:p>
+            <a:r>
+              <a:rPr lang="en-GB" dirty="0"/>
+              <a:t>Correction/Update from Last Week</a:t>
+            </a:r>
+          </a:p>
+        </p:txBody>
+      </p:sp>
+      <p:sp>
+        <p:nvSpPr>
+          <p:cNvPr id="3" name="Content Placeholder 2">
+            <a:extLst>
+              <a:ext uri="{FF2B5EF4-FFF2-40B4-BE49-F238E27FC236}">
+                <a16:creationId xmlns:a16="http://schemas.microsoft.com/office/drawing/2014/main" id="{4BC3D364-C29C-EADB-A40A-DF45E94418A7}"/>
+              </a:ext>
+            </a:extLst>
+          </p:cNvPr>
+          <p:cNvSpPr>
+            <a:spLocks noGrp="1"/>
+          </p:cNvSpPr>
+          <p:nvPr>
+            <p:ph idx="1"/>
+          </p:nvPr>
+        </p:nvSpPr>
+        <p:spPr>
+          <a:xfrm>
+            <a:off x="838200" y="1343818"/>
+            <a:ext cx="10515600" cy="4833145"/>
+          </a:xfrm>
+        </p:spPr>
+        <p:txBody>
+          <a:bodyPr/>
+          <a:lstStyle/>
+          <a:p>
+            <a:r>
+              <a:rPr lang="en-GB" dirty="0"/>
+              <a:t>The output shown last week was an artifact of low shot rate coupled with </a:t>
+            </a:r>
+            <a:r>
+              <a:rPr lang="en-GB"/>
+              <a:t>low post-selection </a:t>
+            </a:r>
+            <a:r>
+              <a:rPr lang="en-GB" dirty="0"/>
+              <a:t>success</a:t>
+            </a:r>
+          </a:p>
+        </p:txBody>
+      </p:sp>
+      <p:pic>
+        <p:nvPicPr>
+          <p:cNvPr id="5" name="Picture 4">
+            <a:extLst>
+              <a:ext uri="{FF2B5EF4-FFF2-40B4-BE49-F238E27FC236}">
+                <a16:creationId xmlns:a16="http://schemas.microsoft.com/office/drawing/2014/main" id="{7AFD5A04-C351-9B67-AC38-CC976141A5A5}"/>
+              </a:ext>
+            </a:extLst>
+          </p:cNvPr>
+          <p:cNvPicPr>
+            <a:picLocks noChangeAspect="1"/>
+          </p:cNvPicPr>
+          <p:nvPr/>
+        </p:nvPicPr>
+        <p:blipFill>
+          <a:blip r:embed="rId2"/>
+          <a:stretch>
+            <a:fillRect/>
+          </a:stretch>
+        </p:blipFill>
+        <p:spPr>
+          <a:xfrm>
+            <a:off x="4089400" y="2099853"/>
+            <a:ext cx="7264400" cy="4739892"/>
+          </a:xfrm>
+          <a:prstGeom prst="rect">
+            <a:avLst/>
+          </a:prstGeom>
+        </p:spPr>
+      </p:pic>
+      <p:pic>
+        <p:nvPicPr>
+          <p:cNvPr id="6" name="Picture 5">
+            <a:extLst>
+              <a:ext uri="{FF2B5EF4-FFF2-40B4-BE49-F238E27FC236}">
+                <a16:creationId xmlns:a16="http://schemas.microsoft.com/office/drawing/2014/main" id="{D738BCE2-391C-390C-DB24-82B1B314335B}"/>
+              </a:ext>
+            </a:extLst>
+          </p:cNvPr>
+          <p:cNvPicPr>
+            <a:picLocks noChangeAspect="1"/>
+          </p:cNvPicPr>
+          <p:nvPr/>
+        </p:nvPicPr>
+        <p:blipFill>
+          <a:blip r:embed="rId3"/>
+          <a:stretch>
+            <a:fillRect/>
+          </a:stretch>
+        </p:blipFill>
+        <p:spPr>
+          <a:xfrm>
+            <a:off x="70636" y="2892010"/>
+            <a:ext cx="4018764" cy="2622172"/>
+          </a:xfrm>
+          <a:prstGeom prst="rect">
+            <a:avLst/>
+          </a:prstGeom>
+        </p:spPr>
+      </p:pic>
+    </p:spTree>
+    <p:extLst>
+      <p:ext uri="{BB962C8B-B14F-4D97-AF65-F5344CB8AC3E}">
+        <p14:creationId xmlns:p14="http://schemas.microsoft.com/office/powerpoint/2010/main" val="20091179"/>
+      </p:ext>
+    </p:extLst>
+  </p:cSld>
+  <p:clrMapOvr>
+    <a:masterClrMapping/>
+  </p:clrMapOvr>
+</p:sld>
+</file>
+
+<file path=ppt/slides/slide31.xml><?xml version="1.0" encoding="utf-8"?>
+<p:sld xmlns:a="http://schemas.openxmlformats.org/drawingml/2006/main" xmlns:r="http://schemas.openxmlformats.org/officeDocument/2006/relationships" xmlns:p="http://schemas.openxmlformats.org/presentationml/2006/main">
+  <p:cSld>
+    <p:spTree>
+      <p:nvGrpSpPr>
+        <p:cNvPr id="1" name=""/>
+        <p:cNvGrpSpPr/>
+        <p:nvPr/>
+      </p:nvGrpSpPr>
+      <p:grpSpPr>
+        <a:xfrm>
+          <a:off x="0" y="0"/>
+          <a:ext cx="0" cy="0"/>
+          <a:chOff x="0" y="0"/>
+          <a:chExt cx="0" cy="0"/>
+        </a:xfrm>
+      </p:grpSpPr>
+      <p:sp>
+        <p:nvSpPr>
+          <p:cNvPr id="2" name="Title 1">
+            <a:extLst>
+              <a:ext uri="{FF2B5EF4-FFF2-40B4-BE49-F238E27FC236}">
+                <a16:creationId xmlns:a16="http://schemas.microsoft.com/office/drawing/2014/main" id="{2F80CB3C-0641-B2A1-7A0F-03AF25D07894}"/>
+              </a:ext>
+            </a:extLst>
+          </p:cNvPr>
+          <p:cNvSpPr>
+            <a:spLocks noGrp="1"/>
+          </p:cNvSpPr>
+          <p:nvPr>
+            <p:ph type="title"/>
+          </p:nvPr>
+        </p:nvSpPr>
+        <p:spPr/>
+        <p:txBody>
+          <a:bodyPr/>
+          <a:lstStyle/>
+          <a:p>
+            <a:r>
+              <a:rPr lang="en-GB" dirty="0"/>
+              <a:t>Second version of Hadamard Test</a:t>
+            </a:r>
+          </a:p>
+        </p:txBody>
+      </p:sp>
+      <p:pic>
+        <p:nvPicPr>
+          <p:cNvPr id="4" name="Picture 3">
+            <a:extLst>
+              <a:ext uri="{FF2B5EF4-FFF2-40B4-BE49-F238E27FC236}">
+                <a16:creationId xmlns:a16="http://schemas.microsoft.com/office/drawing/2014/main" id="{FB681FBB-F73E-ACFE-F555-A1E11AA85D6F}"/>
+              </a:ext>
+            </a:extLst>
+          </p:cNvPr>
+          <p:cNvPicPr>
+            <a:picLocks noChangeAspect="1"/>
+          </p:cNvPicPr>
+          <p:nvPr/>
+        </p:nvPicPr>
+        <p:blipFill>
+          <a:blip r:embed="rId2"/>
+          <a:stretch>
+            <a:fillRect/>
+          </a:stretch>
+        </p:blipFill>
+        <p:spPr>
+          <a:xfrm>
+            <a:off x="476250" y="1474787"/>
+            <a:ext cx="7943850" cy="5183221"/>
+          </a:xfrm>
+          <a:prstGeom prst="rect">
+            <a:avLst/>
+          </a:prstGeom>
+        </p:spPr>
+      </p:pic>
+      <p:pic>
+        <p:nvPicPr>
+          <p:cNvPr id="5" name="Picture 4">
+            <a:extLst>
+              <a:ext uri="{FF2B5EF4-FFF2-40B4-BE49-F238E27FC236}">
+                <a16:creationId xmlns:a16="http://schemas.microsoft.com/office/drawing/2014/main" id="{5CDDA779-4B87-E5AB-2AF9-DC6FE8374FF6}"/>
+              </a:ext>
+            </a:extLst>
+          </p:cNvPr>
+          <p:cNvPicPr>
+            <a:picLocks noChangeAspect="1"/>
+          </p:cNvPicPr>
+          <p:nvPr/>
+        </p:nvPicPr>
+        <p:blipFill>
+          <a:blip r:embed="rId3"/>
+          <a:stretch>
+            <a:fillRect/>
+          </a:stretch>
+        </p:blipFill>
+        <p:spPr>
+          <a:xfrm>
+            <a:off x="8782050" y="0"/>
+            <a:ext cx="3263900" cy="2473336"/>
+          </a:xfrm>
+          <a:prstGeom prst="rect">
+            <a:avLst/>
+          </a:prstGeom>
+        </p:spPr>
+      </p:pic>
+      <p:sp>
+        <p:nvSpPr>
+          <p:cNvPr id="6" name="TextBox 5">
+            <a:extLst>
+              <a:ext uri="{FF2B5EF4-FFF2-40B4-BE49-F238E27FC236}">
+                <a16:creationId xmlns:a16="http://schemas.microsoft.com/office/drawing/2014/main" id="{8E22569B-EDBB-052E-4C7C-313EB9EE4F6C}"/>
+              </a:ext>
+            </a:extLst>
+          </p:cNvPr>
+          <p:cNvSpPr txBox="1"/>
+          <p:nvPr/>
+        </p:nvSpPr>
+        <p:spPr>
+          <a:xfrm>
+            <a:off x="8420100" y="3604732"/>
+            <a:ext cx="3694257" cy="923330"/>
+          </a:xfrm>
+          <a:prstGeom prst="rect">
+            <a:avLst/>
+          </a:prstGeom>
+          <a:noFill/>
+        </p:spPr>
+        <p:txBody>
+          <a:bodyPr wrap="square" rtlCol="0">
+            <a:spAutoFit/>
+          </a:bodyPr>
+          <a:lstStyle/>
+          <a:p>
+            <a:r>
+              <a:rPr lang="en-GB" dirty="0"/>
+              <a:t>Expected output is uniform superposition over qubits 1, 3, 4 but qubit 2 is always in the 0 state.</a:t>
+            </a:r>
+          </a:p>
+        </p:txBody>
+      </p:sp>
+    </p:spTree>
+    <p:extLst>
+      <p:ext uri="{BB962C8B-B14F-4D97-AF65-F5344CB8AC3E}">
+        <p14:creationId xmlns:p14="http://schemas.microsoft.com/office/powerpoint/2010/main" val="2499215127"/>
+      </p:ext>
+    </p:extLst>
+  </p:cSld>
+  <p:clrMapOvr>
+    <a:masterClrMapping/>
+  </p:clrMapOvr>
+</p:sld>
+</file>
+
+<file path=ppt/slides/slide32.xml><?xml version="1.0" encoding="utf-8"?>
+<p:sld xmlns:a="http://schemas.openxmlformats.org/drawingml/2006/main" xmlns:r="http://schemas.openxmlformats.org/officeDocument/2006/relationships" xmlns:p="http://schemas.openxmlformats.org/presentationml/2006/main">
+  <p:cSld>
+    <p:spTree>
+      <p:nvGrpSpPr>
+        <p:cNvPr id="1" name=""/>
+        <p:cNvGrpSpPr/>
+        <p:nvPr/>
+      </p:nvGrpSpPr>
+      <p:grpSpPr>
+        <a:xfrm>
+          <a:off x="0" y="0"/>
+          <a:ext cx="0" cy="0"/>
+          <a:chOff x="0" y="0"/>
+          <a:chExt cx="0" cy="0"/>
+        </a:xfrm>
+      </p:grpSpPr>
+      <p:sp>
+        <p:nvSpPr>
+          <p:cNvPr id="2" name="Title 1">
+            <a:extLst>
+              <a:ext uri="{FF2B5EF4-FFF2-40B4-BE49-F238E27FC236}">
+                <a16:creationId xmlns:a16="http://schemas.microsoft.com/office/drawing/2014/main" id="{64817321-986E-5A57-B090-62B1B9A4AFF9}"/>
+              </a:ext>
+            </a:extLst>
+          </p:cNvPr>
+          <p:cNvSpPr>
+            <a:spLocks noGrp="1"/>
+          </p:cNvSpPr>
+          <p:nvPr>
+            <p:ph type="title"/>
+          </p:nvPr>
+        </p:nvSpPr>
+        <p:spPr/>
+        <p:txBody>
+          <a:bodyPr/>
+          <a:lstStyle/>
+          <a:p>
+            <a:r>
+              <a:rPr lang="en-GB" dirty="0"/>
+              <a:t>How to enforce Fault-Tolerance?</a:t>
+            </a:r>
+          </a:p>
+        </p:txBody>
+      </p:sp>
+      <p:pic>
+        <p:nvPicPr>
+          <p:cNvPr id="5" name="Picture 4">
+            <a:extLst>
+              <a:ext uri="{FF2B5EF4-FFF2-40B4-BE49-F238E27FC236}">
+                <a16:creationId xmlns:a16="http://schemas.microsoft.com/office/drawing/2014/main" id="{74C58CB6-4A38-B9CF-5BC0-9FFCDE92937F}"/>
+              </a:ext>
+            </a:extLst>
+          </p:cNvPr>
+          <p:cNvPicPr>
+            <a:picLocks noChangeAspect="1"/>
+          </p:cNvPicPr>
+          <p:nvPr/>
+        </p:nvPicPr>
+        <p:blipFill>
+          <a:blip r:embed="rId2"/>
+          <a:stretch>
+            <a:fillRect/>
+          </a:stretch>
+        </p:blipFill>
+        <p:spPr>
+          <a:xfrm>
+            <a:off x="5486399" y="1863880"/>
+            <a:ext cx="6160281" cy="4409649"/>
+          </a:xfrm>
+          <a:prstGeom prst="rect">
+            <a:avLst/>
+          </a:prstGeom>
+        </p:spPr>
+      </p:pic>
+      <p:pic>
+        <p:nvPicPr>
+          <p:cNvPr id="6" name="Picture 5">
+            <a:extLst>
+              <a:ext uri="{FF2B5EF4-FFF2-40B4-BE49-F238E27FC236}">
+                <a16:creationId xmlns:a16="http://schemas.microsoft.com/office/drawing/2014/main" id="{3ED6A2C6-12F5-94FF-AF9D-DE35BFFF1AFF}"/>
+              </a:ext>
+            </a:extLst>
+          </p:cNvPr>
+          <p:cNvPicPr>
+            <a:picLocks noChangeAspect="1"/>
+          </p:cNvPicPr>
+          <p:nvPr/>
+        </p:nvPicPr>
+        <p:blipFill>
+          <a:blip r:embed="rId3"/>
+          <a:stretch>
+            <a:fillRect/>
+          </a:stretch>
+        </p:blipFill>
+        <p:spPr>
+          <a:xfrm>
+            <a:off x="838200" y="2805412"/>
+            <a:ext cx="4545329" cy="2526586"/>
+          </a:xfrm>
+          <a:prstGeom prst="rect">
+            <a:avLst/>
+          </a:prstGeom>
+        </p:spPr>
+      </p:pic>
+    </p:spTree>
+    <p:extLst>
+      <p:ext uri="{BB962C8B-B14F-4D97-AF65-F5344CB8AC3E}">
+        <p14:creationId xmlns:p14="http://schemas.microsoft.com/office/powerpoint/2010/main" val="3646509164"/>
       </p:ext>
     </p:extLst>
   </p:cSld>

</xml_diff>